<commit_message>
ajustando wireframes y docs
</commit_message>
<xml_diff>
--- a/AuraHealth - Demo Sprint 2.pptx
+++ b/AuraHealth - Demo Sprint 2.pptx
@@ -903,7 +903,7 @@
           </a:prstGeom>
           <a:extLst>
             <a:ext uri="{C572A759-6A51-4108-AA02-DFA0A04FC94B}">
-              <ma14:wrappingTextBoxFlag xmlns="" xmlns:ma14="http://schemas.microsoft.com/office/mac/drawingml/2011/main" val="0"/>
+              <ma14:wrappingTextBoxFlag xmlns:ma14="http://schemas.microsoft.com/office/mac/drawingml/2011/main" xmlns="" val="0"/>
             </a:ext>
           </a:extLst>
         </p:spPr>
@@ -978,7 +978,7 @@
           </a:prstGeom>
           <a:extLst>
             <a:ext uri="{C572A759-6A51-4108-AA02-DFA0A04FC94B}">
-              <ma14:wrappingTextBoxFlag xmlns="" xmlns:ma14="http://schemas.microsoft.com/office/mac/drawingml/2011/main" val="0"/>
+              <ma14:wrappingTextBoxFlag xmlns:ma14="http://schemas.microsoft.com/office/mac/drawingml/2011/main" xmlns="" val="0"/>
             </a:ext>
           </a:extLst>
         </p:spPr>
@@ -2337,7 +2337,7 @@
           </a:prstGeom>
           <a:extLst>
             <a:ext uri="{C572A759-6A51-4108-AA02-DFA0A04FC94B}">
-              <ma14:wrappingTextBoxFlag xmlns="" xmlns:ma14="http://schemas.microsoft.com/office/mac/drawingml/2011/main" val="0"/>
+              <ma14:wrappingTextBoxFlag xmlns:ma14="http://schemas.microsoft.com/office/mac/drawingml/2011/main" xmlns="" val="0"/>
             </a:ext>
           </a:extLst>
         </p:spPr>
@@ -2900,45 +2900,6 @@
       </p:sp>
       <p:sp>
         <p:nvSpPr>
-          <p:cNvPr id="8" name="Text 5"/>
-          <p:cNvSpPr txBox="1"/>
-          <p:nvPr/>
-        </p:nvSpPr>
-        <p:spPr>
-          <a:xfrm>
-            <a:off x="960120" y="5806440"/>
-            <a:ext cx="4572000" cy="365760"/>
-          </a:xfrm>
-          <a:prstGeom prst="rect">
-            <a:avLst/>
-          </a:prstGeom>
-          <a:noFill/>
-          <a:ln/>
-        </p:spPr>
-        <p:txBody>
-          <a:bodyPr wrap="square" lIns="0" tIns="0" rIns="0" bIns="0" rtlCol="0" anchor="ctr"/>
-          <a:lstStyle/>
-          <a:p>
-            <a:pPr marL="0" indent="0">
-              <a:buNone/>
-            </a:pPr>
-            <a:r>
-              <a:rPr lang="en-US" sz="1150" i="1" dirty="0">
-                <a:solidFill>
-                  <a:srgbClr val="3E5E5A"/>
-                </a:solidFill>
-                <a:latin typeface="Calibri" pitchFamily="34" charset="0"/>
-                <a:ea typeface="Calibri" pitchFamily="34" charset="-122"/>
-                <a:cs typeface="Calibri" pitchFamily="34" charset="-120"/>
-              </a:rPr>
-              <a:t>+ reserva de 3 puntos para corrección de bugs del Sprint 2</a:t>
-            </a:r>
-            <a:endParaRPr lang="en-US" sz="1150" dirty="0"/>
-          </a:p>
-        </p:txBody>
-      </p:sp>
-      <p:sp>
-        <p:nvSpPr>
           <p:cNvPr id="9" name="Shape 6"/>
           <p:cNvSpPr/>
           <p:nvPr/>
@@ -3102,28 +3063,6 @@
               </a:rPr>
               <a:t>Cantidad de historias de usuario implementadas por sprint: A completar</a:t>
             </a:r>
-            <a:r>
-              <a:rPr lang="en-US" sz="1150" dirty="0" err="1">
-                <a:solidFill>
-                  <a:srgbClr val="1B1B1B"/>
-                </a:solidFill>
-                <a:latin typeface="Calibri" pitchFamily="34" charset="0"/>
-                <a:ea typeface="Calibri" pitchFamily="34" charset="-122"/>
-                <a:cs typeface="Calibri" pitchFamily="34" charset="-120"/>
-              </a:rPr>
-              <a:t/>
-            </a:r>
-            <a:r>
-              <a:rPr lang="en-US" sz="1150" dirty="0">
-                <a:solidFill>
-                  <a:srgbClr val="1B1B1B"/>
-                </a:solidFill>
-                <a:latin typeface="Calibri" pitchFamily="34" charset="0"/>
-                <a:ea typeface="Calibri" pitchFamily="34" charset="-122"/>
-                <a:cs typeface="Calibri" pitchFamily="34" charset="-120"/>
-              </a:rPr>
-              <a:t/>
-            </a:r>
             <a:endParaRPr lang="en-US" sz="1150" dirty="0"/>
           </a:p>
           <a:p>
@@ -3145,28 +3084,6 @@
               </a:rPr>
               <a:t>Cantidad de bugs solucionados: A completar</a:t>
             </a:r>
-            <a:r>
-              <a:rPr lang="en-US" sz="1150" dirty="0" err="1">
-                <a:solidFill>
-                  <a:srgbClr val="1B1B1B"/>
-                </a:solidFill>
-                <a:latin typeface="Calibri" pitchFamily="34" charset="0"/>
-                <a:ea typeface="Calibri" pitchFamily="34" charset="-122"/>
-                <a:cs typeface="Calibri" pitchFamily="34" charset="-120"/>
-              </a:rPr>
-              <a:t/>
-            </a:r>
-            <a:r>
-              <a:rPr lang="en-US" sz="1150" dirty="0">
-                <a:solidFill>
-                  <a:srgbClr val="1B1B1B"/>
-                </a:solidFill>
-                <a:latin typeface="Calibri" pitchFamily="34" charset="0"/>
-                <a:ea typeface="Calibri" pitchFamily="34" charset="-122"/>
-                <a:cs typeface="Calibri" pitchFamily="34" charset="-120"/>
-              </a:rPr>
-              <a:t/>
-            </a:r>
             <a:endParaRPr lang="en-US" sz="1150" dirty="0"/>
           </a:p>
           <a:p>
@@ -3188,28 +3105,6 @@
               </a:rPr>
               <a:t>Cantidad de bugs/errores encontrados luego de cada feature implementada: A completar</a:t>
             </a:r>
-            <a:r>
-              <a:rPr lang="en-US" sz="1150" dirty="0" err="1">
-                <a:solidFill>
-                  <a:srgbClr val="1B1B1B"/>
-                </a:solidFill>
-                <a:latin typeface="Calibri" pitchFamily="34" charset="0"/>
-                <a:ea typeface="Calibri" pitchFamily="34" charset="-122"/>
-                <a:cs typeface="Calibri" pitchFamily="34" charset="-120"/>
-              </a:rPr>
-              <a:t/>
-            </a:r>
-            <a:r>
-              <a:rPr lang="en-US" sz="1150" dirty="0">
-                <a:solidFill>
-                  <a:srgbClr val="1B1B1B"/>
-                </a:solidFill>
-                <a:latin typeface="Calibri" pitchFamily="34" charset="0"/>
-                <a:ea typeface="Calibri" pitchFamily="34" charset="-122"/>
-                <a:cs typeface="Calibri" pitchFamily="34" charset="-120"/>
-              </a:rPr>
-              <a:t/>
-            </a:r>
             <a:endParaRPr lang="en-US" sz="1150" dirty="0"/>
           </a:p>
           <a:p>
@@ -3231,17 +3126,6 @@
               </a:rPr>
               <a:t>Cantidad de requerimientos implementados y aprobados sobre el total: A completar</a:t>
             </a:r>
-            <a:r>
-              <a:rPr lang="en-US" sz="1150">
-                <a:solidFill>
-                  <a:srgbClr val="1B1B1B"/>
-                </a:solidFill>
-                <a:latin typeface="Calibri" pitchFamily="34" charset="0"/>
-                <a:ea typeface="Calibri" pitchFamily="34" charset="-122"/>
-                <a:cs typeface="Calibri" pitchFamily="34" charset="-120"/>
-              </a:rPr>
-              <a:t/>
-            </a:r>
             <a:endParaRPr lang="en-US" sz="1150" dirty="0"/>
           </a:p>
           <a:p>
@@ -3263,50 +3147,6 @@
               </a:rPr>
               <a:t>Cantidad de tareas en curso simultáneamente: A completar</a:t>
             </a:r>
-            <a:r>
-              <a:rPr lang="en-US" sz="1150" dirty="0" err="1">
-                <a:solidFill>
-                  <a:srgbClr val="1B1B1B"/>
-                </a:solidFill>
-                <a:latin typeface="Calibri" pitchFamily="34" charset="0"/>
-                <a:ea typeface="Calibri" pitchFamily="34" charset="-122"/>
-                <a:cs typeface="Calibri" pitchFamily="34" charset="-120"/>
-              </a:rPr>
-              <a:t/>
-            </a:r>
-            <a:r>
-              <a:rPr lang="en-US" sz="1150" dirty="0">
-                <a:solidFill>
-                  <a:srgbClr val="1B1B1B"/>
-                </a:solidFill>
-                <a:latin typeface="Calibri" pitchFamily="34" charset="0"/>
-                <a:ea typeface="Calibri" pitchFamily="34" charset="-122"/>
-                <a:cs typeface="Calibri" pitchFamily="34" charset="-120"/>
-              </a:rPr>
-              <a:t/>
-            </a:r>
-            <a:r>
-              <a:rPr lang="en-US" sz="1150" dirty="0" err="1">
-                <a:solidFill>
-                  <a:srgbClr val="1B1B1B"/>
-                </a:solidFill>
-                <a:latin typeface="Calibri" pitchFamily="34" charset="0"/>
-                <a:ea typeface="Calibri" pitchFamily="34" charset="-122"/>
-                <a:cs typeface="Calibri" pitchFamily="34" charset="-120"/>
-              </a:rPr>
-              <a:t/>
-            </a:r>
-            <a:r>
-              <a:rPr lang="en-US" sz="1150" dirty="0">
-                <a:solidFill>
-                  <a:srgbClr val="1B1B1B"/>
-                </a:solidFill>
-                <a:latin typeface="Calibri" pitchFamily="34" charset="0"/>
-                <a:ea typeface="Calibri" pitchFamily="34" charset="-122"/>
-                <a:cs typeface="Calibri" pitchFamily="34" charset="-120"/>
-              </a:rPr>
-              <a:t/>
-            </a:r>
             <a:endParaRPr lang="en-US" sz="1150" dirty="0"/>
           </a:p>
           <a:p>
@@ -3328,39 +3168,6 @@
               </a:rPr>
               <a:t>Tiempo total desde que una tarea entra al backlog hasta que llega a producción: A completar</a:t>
             </a:r>
-            <a:r>
-              <a:rPr lang="en-US" sz="1150" dirty="0" err="1">
-                <a:solidFill>
-                  <a:srgbClr val="1B1B1B"/>
-                </a:solidFill>
-                <a:latin typeface="Calibri" pitchFamily="34" charset="0"/>
-                <a:ea typeface="Calibri" pitchFamily="34" charset="-122"/>
-                <a:cs typeface="Calibri" pitchFamily="34" charset="-120"/>
-              </a:rPr>
-              <a:t/>
-            </a:r>
-            <a:r>
-              <a:rPr lang="en-US" sz="1150" dirty="0">
-                <a:solidFill>
-                  <a:srgbClr val="1B1B1B"/>
-                </a:solidFill>
-                <a:latin typeface="Calibri" pitchFamily="34" charset="0"/>
-                <a:ea typeface="Calibri" pitchFamily="34" charset="-122"/>
-                <a:cs typeface="Calibri" pitchFamily="34" charset="-120"/>
-              </a:rPr>
-              <a:t/>
-            </a:r>
-            <a:r>
-              <a:rPr lang="en-US" sz="1150" dirty="0" err="1">
-                <a:solidFill>
-                  <a:srgbClr val="1B1B1B"/>
-                </a:solidFill>
-                <a:latin typeface="Calibri" pitchFamily="34" charset="0"/>
-                <a:ea typeface="Calibri" pitchFamily="34" charset="-122"/>
-                <a:cs typeface="Calibri" pitchFamily="34" charset="-120"/>
-              </a:rPr>
-              <a:t/>
-            </a:r>
             <a:endParaRPr lang="en-US" sz="1150" dirty="0"/>
           </a:p>
           <a:p>
@@ -3381,105 +3188,6 @@
                 <a:cs typeface="Calibri" pitchFamily="34" charset="-120"/>
               </a:rPr>
               <a:t>Cantidad de HU que no se terminan en el sprint sobre el total de HU del sprint: A completar</a:t>
-            </a:r>
-            <a:r>
-              <a:rPr lang="en-US" sz="1150" dirty="0">
-                <a:solidFill>
-                  <a:srgbClr val="1B1B1B"/>
-                </a:solidFill>
-                <a:latin typeface="Calibri" pitchFamily="34" charset="0"/>
-                <a:ea typeface="Calibri" pitchFamily="34" charset="-122"/>
-                <a:cs typeface="Calibri" pitchFamily="34" charset="-120"/>
-              </a:rPr>
-              <a:t/>
-            </a:r>
-            <a:r>
-              <a:rPr lang="en-US" sz="1150" dirty="0" err="1">
-                <a:solidFill>
-                  <a:srgbClr val="1B1B1B"/>
-                </a:solidFill>
-                <a:latin typeface="Calibri" pitchFamily="34" charset="0"/>
-                <a:ea typeface="Calibri" pitchFamily="34" charset="-122"/>
-                <a:cs typeface="Calibri" pitchFamily="34" charset="-120"/>
-              </a:rPr>
-              <a:t/>
-            </a:r>
-            <a:r>
-              <a:rPr lang="en-US" sz="1150" dirty="0">
-                <a:solidFill>
-                  <a:srgbClr val="1B1B1B"/>
-                </a:solidFill>
-                <a:latin typeface="Calibri" pitchFamily="34" charset="0"/>
-                <a:ea typeface="Calibri" pitchFamily="34" charset="-122"/>
-                <a:cs typeface="Calibri" pitchFamily="34" charset="-120"/>
-              </a:rPr>
-              <a:t/>
-            </a:r>
-            <a:r>
-              <a:rPr lang="en-US" sz="1150" dirty="0" err="1">
-                <a:solidFill>
-                  <a:srgbClr val="1B1B1B"/>
-                </a:solidFill>
-                <a:latin typeface="Calibri" pitchFamily="34" charset="0"/>
-                <a:ea typeface="Calibri" pitchFamily="34" charset="-122"/>
-                <a:cs typeface="Calibri" pitchFamily="34" charset="-120"/>
-              </a:rPr>
-              <a:t/>
-            </a:r>
-            <a:r>
-              <a:rPr lang="en-US" sz="1150" dirty="0">
-                <a:solidFill>
-                  <a:srgbClr val="1B1B1B"/>
-                </a:solidFill>
-                <a:latin typeface="Calibri" pitchFamily="34" charset="0"/>
-                <a:ea typeface="Calibri" pitchFamily="34" charset="-122"/>
-                <a:cs typeface="Calibri" pitchFamily="34" charset="-120"/>
-              </a:rPr>
-              <a:t/>
-            </a:r>
-            <a:r>
-              <a:rPr lang="en-US" sz="1150" dirty="0" err="1">
-                <a:solidFill>
-                  <a:srgbClr val="1B1B1B"/>
-                </a:solidFill>
-                <a:latin typeface="Calibri" pitchFamily="34" charset="0"/>
-                <a:ea typeface="Calibri" pitchFamily="34" charset="-122"/>
-                <a:cs typeface="Calibri" pitchFamily="34" charset="-120"/>
-              </a:rPr>
-              <a:t/>
-            </a:r>
-            <a:r>
-              <a:rPr lang="en-US" sz="1150" dirty="0">
-                <a:solidFill>
-                  <a:srgbClr val="1B1B1B"/>
-                </a:solidFill>
-                <a:latin typeface="Calibri" pitchFamily="34" charset="0"/>
-                <a:ea typeface="Calibri" pitchFamily="34" charset="-122"/>
-                <a:cs typeface="Calibri" pitchFamily="34" charset="-120"/>
-              </a:rPr>
-              <a:t/>
-            </a:r>
-            <a:r>
-              <a:rPr lang="en-US" sz="1150" dirty="0" err="1">
-                <a:solidFill>
-                  <a:srgbClr val="1B1B1B"/>
-                </a:solidFill>
-                <a:latin typeface="Calibri" pitchFamily="34" charset="0"/>
-                <a:ea typeface="Calibri" pitchFamily="34" charset="-122"/>
-                <a:cs typeface="Calibri" pitchFamily="34" charset="-120"/>
-              </a:rPr>
-              <a:t/>
-            </a:r>
-            <a:r>
-              <a:rPr lang="en-US" sz="1150" dirty="0">
-                <a:solidFill>
-                  <a:srgbClr val="1B1B1B"/>
-                </a:solidFill>
-                <a:latin typeface="Calibri" pitchFamily="34" charset="0"/>
-                <a:ea typeface="Calibri" pitchFamily="34" charset="-122"/>
-                <a:cs typeface="Calibri" pitchFamily="34" charset="-120"/>
-              </a:rPr>
-              <a:t/>
             </a:r>
             <a:endParaRPr lang="en-US" sz="1150" dirty="0"/>
           </a:p>
@@ -3544,7 +3252,7 @@
           </a:prstGeom>
           <a:extLst>
             <a:ext uri="{C572A759-6A51-4108-AA02-DFA0A04FC94B}">
-              <ma14:wrappingTextBoxFlag xmlns="" xmlns:ma14="http://schemas.microsoft.com/office/mac/drawingml/2011/main" val="0"/>
+              <ma14:wrappingTextBoxFlag xmlns:ma14="http://schemas.microsoft.com/office/mac/drawingml/2011/main" xmlns="" val="0"/>
             </a:ext>
           </a:extLst>
         </p:spPr>
@@ -3571,7 +3279,7 @@
       </p:sp>
       <p:sp>
         <p:nvSpPr>
-          <p:cNvPr id="7" name="Text 4"/>
+          <p:cNvPr id="15" name="Text 4"/>
           <p:cNvSpPr txBox="1"/>
           <p:nvPr/>
         </p:nvSpPr>
@@ -4698,7 +4406,7 @@
           </a:prstGeom>
           <a:extLst>
             <a:ext uri="{C572A759-6A51-4108-AA02-DFA0A04FC94B}">
-              <ma14:wrappingTextBoxFlag xmlns="" xmlns:ma14="http://schemas.microsoft.com/office/mac/drawingml/2011/main" val="0"/>
+              <ma14:wrappingTextBoxFlag xmlns:ma14="http://schemas.microsoft.com/office/mac/drawingml/2011/main" xmlns="" val="0"/>
             </a:ext>
           </a:extLst>
         </p:spPr>

</xml_diff>

<commit_message>
Plan de demo y slides editadas
</commit_message>
<xml_diff>
--- a/AuraHealth - Demo Sprint 2.pptx
+++ b/AuraHealth - Demo Sprint 2.pptx
@@ -113,6 +113,416 @@
     </p:ext>
   </p:extLst>
 </p:presentation>
+</file>
+
+<file path=ppt/revisionInfo.xml><?xml version="1.0" encoding="utf-8"?>
+<p1510:revInfo xmlns:a="http://schemas.openxmlformats.org/drawingml/2006/main" xmlns:r="http://schemas.openxmlformats.org/officeDocument/2006/relationships" xmlns:p1510="http://schemas.microsoft.com/office/powerpoint/2015/10/main">
+  <p1510:revLst>
+    <p1510:client id="{C599B165-E861-4DCA-BBFC-C5A17A7F5016}" v="8" dt="2026-10-22T18:50:03.033"/>
+  </p1510:revLst>
+</p1510:revInfo>
+</file>
+
+<file path=ppt/changesInfos/changesInfo1.xml><?xml version="1.0" encoding="utf-8"?>
+<pc:chgInfo xmlns:a="http://schemas.openxmlformats.org/drawingml/2006/main" xmlns:r="http://schemas.openxmlformats.org/officeDocument/2006/relationships" xmlns:ac="http://schemas.microsoft.com/office/drawing/2013/main/command" xmlns:pc="http://schemas.microsoft.com/office/powerpoint/2013/main/command">
+  <pc:docChgLst>
+    <pc:chgData name="Agustín Echavarría" userId="0dacd65e5bd92426" providerId="LiveId" clId="{20F5A9F9-590B-4571-87AC-ADBD672ECC31}"/>
+    <pc:docChg chg="undo custSel modSld">
+      <pc:chgData name="Agustín Echavarría" userId="0dacd65e5bd92426" providerId="LiveId" clId="{20F5A9F9-590B-4571-87AC-ADBD672ECC31}" dt="2026-10-22T19:32:40.835" v="1320" actId="20577"/>
+      <pc:docMkLst>
+        <pc:docMk/>
+      </pc:docMkLst>
+      <pc:sldChg chg="modSp mod">
+        <pc:chgData name="Agustín Echavarría" userId="0dacd65e5bd92426" providerId="LiveId" clId="{20F5A9F9-590B-4571-87AC-ADBD672ECC31}" dt="2026-10-21T19:43:03.389" v="687" actId="20577"/>
+        <pc:sldMkLst>
+          <pc:docMk/>
+          <pc:sldMk cId="0" sldId="256"/>
+        </pc:sldMkLst>
+        <pc:spChg chg="mod">
+          <ac:chgData name="Agustín Echavarría" userId="0dacd65e5bd92426" providerId="LiveId" clId="{20F5A9F9-590B-4571-87AC-ADBD672ECC31}" dt="2026-10-21T19:21:03.474" v="396" actId="790"/>
+          <ac:spMkLst>
+            <pc:docMk/>
+            <pc:sldMk cId="0" sldId="256"/>
+            <ac:spMk id="2" creationId="{00000000-0000-0000-0000-000000000000}"/>
+          </ac:spMkLst>
+        </pc:spChg>
+        <pc:spChg chg="mod">
+          <ac:chgData name="Agustín Echavarría" userId="0dacd65e5bd92426" providerId="LiveId" clId="{20F5A9F9-590B-4571-87AC-ADBD672ECC31}" dt="2026-10-21T19:21:03.474" v="396" actId="790"/>
+          <ac:spMkLst>
+            <pc:docMk/>
+            <pc:sldMk cId="0" sldId="256"/>
+            <ac:spMk id="3" creationId="{00000000-0000-0000-0000-000000000000}"/>
+          </ac:spMkLst>
+        </pc:spChg>
+        <pc:spChg chg="mod">
+          <ac:chgData name="Agustín Echavarría" userId="0dacd65e5bd92426" providerId="LiveId" clId="{20F5A9F9-590B-4571-87AC-ADBD672ECC31}" dt="2026-10-21T19:21:03.474" v="396" actId="790"/>
+          <ac:spMkLst>
+            <pc:docMk/>
+            <pc:sldMk cId="0" sldId="256"/>
+            <ac:spMk id="4" creationId="{00000000-0000-0000-0000-000000000000}"/>
+          </ac:spMkLst>
+        </pc:spChg>
+        <pc:spChg chg="mod">
+          <ac:chgData name="Agustín Echavarría" userId="0dacd65e5bd92426" providerId="LiveId" clId="{20F5A9F9-590B-4571-87AC-ADBD672ECC31}" dt="2026-10-21T19:21:03.474" v="396" actId="790"/>
+          <ac:spMkLst>
+            <pc:docMk/>
+            <pc:sldMk cId="0" sldId="256"/>
+            <ac:spMk id="6" creationId="{00000000-0000-0000-0000-000000000000}"/>
+          </ac:spMkLst>
+        </pc:spChg>
+        <pc:spChg chg="mod">
+          <ac:chgData name="Agustín Echavarría" userId="0dacd65e5bd92426" providerId="LiveId" clId="{20F5A9F9-590B-4571-87AC-ADBD672ECC31}" dt="2026-10-21T19:21:03.474" v="396" actId="790"/>
+          <ac:spMkLst>
+            <pc:docMk/>
+            <pc:sldMk cId="0" sldId="256"/>
+            <ac:spMk id="7" creationId="{00000000-0000-0000-0000-000000000000}"/>
+          </ac:spMkLst>
+        </pc:spChg>
+        <pc:spChg chg="mod">
+          <ac:chgData name="Agustín Echavarría" userId="0dacd65e5bd92426" providerId="LiveId" clId="{20F5A9F9-590B-4571-87AC-ADBD672ECC31}" dt="2026-10-21T19:43:03.389" v="687" actId="20577"/>
+          <ac:spMkLst>
+            <pc:docMk/>
+            <pc:sldMk cId="0" sldId="256"/>
+            <ac:spMk id="8" creationId="{00000000-0000-0000-0000-000000000000}"/>
+          </ac:spMkLst>
+        </pc:spChg>
+      </pc:sldChg>
+      <pc:sldChg chg="modSp mod">
+        <pc:chgData name="Agustín Echavarría" userId="0dacd65e5bd92426" providerId="LiveId" clId="{20F5A9F9-590B-4571-87AC-ADBD672ECC31}" dt="2026-10-22T19:25:01.644" v="1310" actId="20577"/>
+        <pc:sldMkLst>
+          <pc:docMk/>
+          <pc:sldMk cId="0" sldId="257"/>
+        </pc:sldMkLst>
+        <pc:spChg chg="mod">
+          <ac:chgData name="Agustín Echavarría" userId="0dacd65e5bd92426" providerId="LiveId" clId="{20F5A9F9-590B-4571-87AC-ADBD672ECC31}" dt="2026-10-21T19:21:03.474" v="396" actId="790"/>
+          <ac:spMkLst>
+            <pc:docMk/>
+            <pc:sldMk cId="0" sldId="257"/>
+            <ac:spMk id="2" creationId="{00000000-0000-0000-0000-000000000000}"/>
+          </ac:spMkLst>
+        </pc:spChg>
+        <pc:spChg chg="mod">
+          <ac:chgData name="Agustín Echavarría" userId="0dacd65e5bd92426" providerId="LiveId" clId="{20F5A9F9-590B-4571-87AC-ADBD672ECC31}" dt="2026-10-21T19:21:03.474" v="396" actId="790"/>
+          <ac:spMkLst>
+            <pc:docMk/>
+            <pc:sldMk cId="0" sldId="257"/>
+            <ac:spMk id="3" creationId="{00000000-0000-0000-0000-000000000000}"/>
+          </ac:spMkLst>
+        </pc:spChg>
+        <pc:spChg chg="mod">
+          <ac:chgData name="Agustín Echavarría" userId="0dacd65e5bd92426" providerId="LiveId" clId="{20F5A9F9-590B-4571-87AC-ADBD672ECC31}" dt="2026-10-21T19:21:03.474" v="396" actId="790"/>
+          <ac:spMkLst>
+            <pc:docMk/>
+            <pc:sldMk cId="0" sldId="257"/>
+            <ac:spMk id="6" creationId="{00000000-0000-0000-0000-000000000000}"/>
+          </ac:spMkLst>
+        </pc:spChg>
+        <pc:spChg chg="mod">
+          <ac:chgData name="Agustín Echavarría" userId="0dacd65e5bd92426" providerId="LiveId" clId="{20F5A9F9-590B-4571-87AC-ADBD672ECC31}" dt="2026-10-21T19:45:38.792" v="688" actId="20577"/>
+          <ac:spMkLst>
+            <pc:docMk/>
+            <pc:sldMk cId="0" sldId="257"/>
+            <ac:spMk id="7" creationId="{00000000-0000-0000-0000-000000000000}"/>
+          </ac:spMkLst>
+        </pc:spChg>
+        <pc:spChg chg="mod">
+          <ac:chgData name="Agustín Echavarría" userId="0dacd65e5bd92426" providerId="LiveId" clId="{20F5A9F9-590B-4571-87AC-ADBD672ECC31}" dt="2026-10-21T19:21:03.474" v="396" actId="790"/>
+          <ac:spMkLst>
+            <pc:docMk/>
+            <pc:sldMk cId="0" sldId="257"/>
+            <ac:spMk id="8" creationId="{00000000-0000-0000-0000-000000000000}"/>
+          </ac:spMkLst>
+        </pc:spChg>
+        <pc:spChg chg="mod">
+          <ac:chgData name="Agustín Echavarría" userId="0dacd65e5bd92426" providerId="LiveId" clId="{20F5A9F9-590B-4571-87AC-ADBD672ECC31}" dt="2026-10-22T18:50:22.631" v="967" actId="313"/>
+          <ac:spMkLst>
+            <pc:docMk/>
+            <pc:sldMk cId="0" sldId="257"/>
+            <ac:spMk id="9" creationId="{00000000-0000-0000-0000-000000000000}"/>
+          </ac:spMkLst>
+        </pc:spChg>
+        <pc:spChg chg="mod">
+          <ac:chgData name="Agustín Echavarría" userId="0dacd65e5bd92426" providerId="LiveId" clId="{20F5A9F9-590B-4571-87AC-ADBD672ECC31}" dt="2026-10-21T19:21:03.474" v="396" actId="790"/>
+          <ac:spMkLst>
+            <pc:docMk/>
+            <pc:sldMk cId="0" sldId="257"/>
+            <ac:spMk id="10" creationId="{00000000-0000-0000-0000-000000000000}"/>
+          </ac:spMkLst>
+        </pc:spChg>
+        <pc:spChg chg="mod">
+          <ac:chgData name="Agustín Echavarría" userId="0dacd65e5bd92426" providerId="LiveId" clId="{20F5A9F9-590B-4571-87AC-ADBD672ECC31}" dt="2026-10-21T19:21:03.474" v="396" actId="790"/>
+          <ac:spMkLst>
+            <pc:docMk/>
+            <pc:sldMk cId="0" sldId="257"/>
+            <ac:spMk id="11" creationId="{00000000-0000-0000-0000-000000000000}"/>
+          </ac:spMkLst>
+        </pc:spChg>
+        <pc:spChg chg="mod">
+          <ac:chgData name="Agustín Echavarría" userId="0dacd65e5bd92426" providerId="LiveId" clId="{20F5A9F9-590B-4571-87AC-ADBD672ECC31}" dt="2026-10-22T19:25:01.644" v="1310" actId="20577"/>
+          <ac:spMkLst>
+            <pc:docMk/>
+            <pc:sldMk cId="0" sldId="257"/>
+            <ac:spMk id="13" creationId="{00000000-0000-0000-0000-000000000000}"/>
+          </ac:spMkLst>
+        </pc:spChg>
+        <pc:spChg chg="mod">
+          <ac:chgData name="Agustín Echavarría" userId="0dacd65e5bd92426" providerId="LiveId" clId="{20F5A9F9-590B-4571-87AC-ADBD672ECC31}" dt="2026-10-22T19:20:06.381" v="1296" actId="400"/>
+          <ac:spMkLst>
+            <pc:docMk/>
+            <pc:sldMk cId="0" sldId="257"/>
+            <ac:spMk id="14" creationId="{00000000-0000-0000-0000-000000000000}"/>
+          </ac:spMkLst>
+        </pc:spChg>
+        <pc:spChg chg="mod">
+          <ac:chgData name="Agustín Echavarría" userId="0dacd65e5bd92426" providerId="LiveId" clId="{20F5A9F9-590B-4571-87AC-ADBD672ECC31}" dt="2026-10-21T19:21:03.474" v="396" actId="790"/>
+          <ac:spMkLst>
+            <pc:docMk/>
+            <pc:sldMk cId="0" sldId="257"/>
+            <ac:spMk id="25" creationId="{00000000-0000-0000-0000-000000000000}"/>
+          </ac:spMkLst>
+        </pc:spChg>
+      </pc:sldChg>
+      <pc:sldChg chg="delSp modSp mod">
+        <pc:chgData name="Agustín Echavarría" userId="0dacd65e5bd92426" providerId="LiveId" clId="{20F5A9F9-590B-4571-87AC-ADBD672ECC31}" dt="2026-10-22T19:32:40.835" v="1320" actId="20577"/>
+        <pc:sldMkLst>
+          <pc:docMk/>
+          <pc:sldMk cId="0" sldId="258"/>
+        </pc:sldMkLst>
+        <pc:spChg chg="mod">
+          <ac:chgData name="Agustín Echavarría" userId="0dacd65e5bd92426" providerId="LiveId" clId="{20F5A9F9-590B-4571-87AC-ADBD672ECC31}" dt="2026-10-21T19:21:03.474" v="396" actId="790"/>
+          <ac:spMkLst>
+            <pc:docMk/>
+            <pc:sldMk cId="0" sldId="258"/>
+            <ac:spMk id="2" creationId="{00000000-0000-0000-0000-000000000000}"/>
+          </ac:spMkLst>
+        </pc:spChg>
+        <pc:spChg chg="mod">
+          <ac:chgData name="Agustín Echavarría" userId="0dacd65e5bd92426" providerId="LiveId" clId="{20F5A9F9-590B-4571-87AC-ADBD672ECC31}" dt="2026-10-21T19:21:03.474" v="396" actId="790"/>
+          <ac:spMkLst>
+            <pc:docMk/>
+            <pc:sldMk cId="0" sldId="258"/>
+            <ac:spMk id="3" creationId="{00000000-0000-0000-0000-000000000000}"/>
+          </ac:spMkLst>
+        </pc:spChg>
+        <pc:spChg chg="mod">
+          <ac:chgData name="Agustín Echavarría" userId="0dacd65e5bd92426" providerId="LiveId" clId="{20F5A9F9-590B-4571-87AC-ADBD672ECC31}" dt="2026-10-21T19:21:03.474" v="396" actId="790"/>
+          <ac:spMkLst>
+            <pc:docMk/>
+            <pc:sldMk cId="0" sldId="258"/>
+            <ac:spMk id="4" creationId="{00000000-0000-0000-0000-000000000000}"/>
+          </ac:spMkLst>
+        </pc:spChg>
+        <pc:spChg chg="mod">
+          <ac:chgData name="Agustín Echavarría" userId="0dacd65e5bd92426" providerId="LiveId" clId="{20F5A9F9-590B-4571-87AC-ADBD672ECC31}" dt="2026-10-22T18:51:52.370" v="1046" actId="20577"/>
+          <ac:spMkLst>
+            <pc:docMk/>
+            <pc:sldMk cId="0" sldId="258"/>
+            <ac:spMk id="6" creationId="{00000000-0000-0000-0000-000000000000}"/>
+          </ac:spMkLst>
+        </pc:spChg>
+        <pc:spChg chg="mod">
+          <ac:chgData name="Agustín Echavarría" userId="0dacd65e5bd92426" providerId="LiveId" clId="{20F5A9F9-590B-4571-87AC-ADBD672ECC31}" dt="2026-10-21T19:21:03.474" v="396" actId="790"/>
+          <ac:spMkLst>
+            <pc:docMk/>
+            <pc:sldMk cId="0" sldId="258"/>
+            <ac:spMk id="7" creationId="{00000000-0000-0000-0000-000000000000}"/>
+          </ac:spMkLst>
+        </pc:spChg>
+        <pc:spChg chg="mod">
+          <ac:chgData name="Agustín Echavarría" userId="0dacd65e5bd92426" providerId="LiveId" clId="{20F5A9F9-590B-4571-87AC-ADBD672ECC31}" dt="2026-10-21T19:21:03.474" v="396" actId="790"/>
+          <ac:spMkLst>
+            <pc:docMk/>
+            <pc:sldMk cId="0" sldId="258"/>
+            <ac:spMk id="9" creationId="{00000000-0000-0000-0000-000000000000}"/>
+          </ac:spMkLst>
+        </pc:spChg>
+        <pc:spChg chg="mod">
+          <ac:chgData name="Agustín Echavarría" userId="0dacd65e5bd92426" providerId="LiveId" clId="{20F5A9F9-590B-4571-87AC-ADBD672ECC31}" dt="2026-10-21T19:21:03.474" v="396" actId="790"/>
+          <ac:spMkLst>
+            <pc:docMk/>
+            <pc:sldMk cId="0" sldId="258"/>
+            <ac:spMk id="10" creationId="{00000000-0000-0000-0000-000000000000}"/>
+          </ac:spMkLst>
+        </pc:spChg>
+        <pc:spChg chg="mod">
+          <ac:chgData name="Agustín Echavarría" userId="0dacd65e5bd92426" providerId="LiveId" clId="{20F5A9F9-590B-4571-87AC-ADBD672ECC31}" dt="2026-10-22T19:32:40.835" v="1320" actId="20577"/>
+          <ac:spMkLst>
+            <pc:docMk/>
+            <pc:sldMk cId="0" sldId="258"/>
+            <ac:spMk id="13" creationId="{00000000-0000-0000-0000-000000000000}"/>
+          </ac:spMkLst>
+        </pc:spChg>
+        <pc:spChg chg="del mod">
+          <ac:chgData name="Agustín Echavarría" userId="0dacd65e5bd92426" providerId="LiveId" clId="{20F5A9F9-590B-4571-87AC-ADBD672ECC31}" dt="2026-10-21T19:22:28.630" v="440" actId="478"/>
+          <ac:spMkLst>
+            <pc:docMk/>
+            <pc:sldMk cId="0" sldId="258"/>
+            <ac:spMk id="14" creationId="{00000000-0000-0000-0000-000000000000}"/>
+          </ac:spMkLst>
+        </pc:spChg>
+        <pc:spChg chg="mod">
+          <ac:chgData name="Agustín Echavarría" userId="0dacd65e5bd92426" providerId="LiveId" clId="{20F5A9F9-590B-4571-87AC-ADBD672ECC31}" dt="2026-10-21T19:21:03.474" v="396" actId="790"/>
+          <ac:spMkLst>
+            <pc:docMk/>
+            <pc:sldMk cId="0" sldId="258"/>
+            <ac:spMk id="25" creationId="{00000000-0000-0000-0000-000000000000}"/>
+          </ac:spMkLst>
+        </pc:spChg>
+      </pc:sldChg>
+      <pc:sldChg chg="addSp delSp modSp mod">
+        <pc:chgData name="Agustín Echavarría" userId="0dacd65e5bd92426" providerId="LiveId" clId="{20F5A9F9-590B-4571-87AC-ADBD672ECC31}" dt="2026-10-22T19:24:06.176" v="1306" actId="1076"/>
+        <pc:sldMkLst>
+          <pc:docMk/>
+          <pc:sldMk cId="0" sldId="259"/>
+        </pc:sldMkLst>
+        <pc:spChg chg="mod">
+          <ac:chgData name="Agustín Echavarría" userId="0dacd65e5bd92426" providerId="LiveId" clId="{20F5A9F9-590B-4571-87AC-ADBD672ECC31}" dt="2026-10-21T19:21:03.474" v="396" actId="790"/>
+          <ac:spMkLst>
+            <pc:docMk/>
+            <pc:sldMk cId="0" sldId="259"/>
+            <ac:spMk id="2" creationId="{00000000-0000-0000-0000-000000000000}"/>
+          </ac:spMkLst>
+        </pc:spChg>
+        <pc:spChg chg="mod">
+          <ac:chgData name="Agustín Echavarría" userId="0dacd65e5bd92426" providerId="LiveId" clId="{20F5A9F9-590B-4571-87AC-ADBD672ECC31}" dt="2026-10-21T19:21:03.474" v="396" actId="790"/>
+          <ac:spMkLst>
+            <pc:docMk/>
+            <pc:sldMk cId="0" sldId="259"/>
+            <ac:spMk id="6" creationId="{00000000-0000-0000-0000-000000000000}"/>
+          </ac:spMkLst>
+        </pc:spChg>
+        <pc:spChg chg="mod">
+          <ac:chgData name="Agustín Echavarría" userId="0dacd65e5bd92426" providerId="LiveId" clId="{20F5A9F9-590B-4571-87AC-ADBD672ECC31}" dt="2026-10-22T18:58:42.386" v="1140" actId="20577"/>
+          <ac:spMkLst>
+            <pc:docMk/>
+            <pc:sldMk cId="0" sldId="259"/>
+            <ac:spMk id="7" creationId="{00000000-0000-0000-0000-000000000000}"/>
+          </ac:spMkLst>
+        </pc:spChg>
+        <pc:spChg chg="mod">
+          <ac:chgData name="Agustín Echavarría" userId="0dacd65e5bd92426" providerId="LiveId" clId="{20F5A9F9-590B-4571-87AC-ADBD672ECC31}" dt="2026-10-21T19:21:03.474" v="396" actId="790"/>
+          <ac:spMkLst>
+            <pc:docMk/>
+            <pc:sldMk cId="0" sldId="259"/>
+            <ac:spMk id="8" creationId="{00000000-0000-0000-0000-000000000000}"/>
+          </ac:spMkLst>
+        </pc:spChg>
+        <pc:spChg chg="mod">
+          <ac:chgData name="Agustín Echavarría" userId="0dacd65e5bd92426" providerId="LiveId" clId="{20F5A9F9-590B-4571-87AC-ADBD672ECC31}" dt="2026-10-21T19:21:03.474" v="396" actId="790"/>
+          <ac:spMkLst>
+            <pc:docMk/>
+            <pc:sldMk cId="0" sldId="259"/>
+            <ac:spMk id="9" creationId="{00000000-0000-0000-0000-000000000000}"/>
+          </ac:spMkLst>
+        </pc:spChg>
+        <pc:spChg chg="mod">
+          <ac:chgData name="Agustín Echavarría" userId="0dacd65e5bd92426" providerId="LiveId" clId="{20F5A9F9-590B-4571-87AC-ADBD672ECC31}" dt="2026-10-21T19:21:03.474" v="396" actId="790"/>
+          <ac:spMkLst>
+            <pc:docMk/>
+            <pc:sldMk cId="0" sldId="259"/>
+            <ac:spMk id="11" creationId="{00000000-0000-0000-0000-000000000000}"/>
+          </ac:spMkLst>
+        </pc:spChg>
+        <pc:spChg chg="mod">
+          <ac:chgData name="Agustín Echavarría" userId="0dacd65e5bd92426" providerId="LiveId" clId="{20F5A9F9-590B-4571-87AC-ADBD672ECC31}" dt="2026-10-22T19:06:43.586" v="1224" actId="20577"/>
+          <ac:spMkLst>
+            <pc:docMk/>
+            <pc:sldMk cId="0" sldId="259"/>
+            <ac:spMk id="12" creationId="{00000000-0000-0000-0000-000000000000}"/>
+          </ac:spMkLst>
+        </pc:spChg>
+        <pc:spChg chg="mod">
+          <ac:chgData name="Agustín Echavarría" userId="0dacd65e5bd92426" providerId="LiveId" clId="{20F5A9F9-590B-4571-87AC-ADBD672ECC31}" dt="2026-10-22T19:24:06.176" v="1306" actId="1076"/>
+          <ac:spMkLst>
+            <pc:docMk/>
+            <pc:sldMk cId="0" sldId="259"/>
+            <ac:spMk id="13" creationId="{00000000-0000-0000-0000-000000000000}"/>
+          </ac:spMkLst>
+        </pc:spChg>
+        <pc:spChg chg="mod">
+          <ac:chgData name="Agustín Echavarría" userId="0dacd65e5bd92426" providerId="LiveId" clId="{20F5A9F9-590B-4571-87AC-ADBD672ECC31}" dt="2026-10-22T19:24:06.176" v="1306" actId="1076"/>
+          <ac:spMkLst>
+            <pc:docMk/>
+            <pc:sldMk cId="0" sldId="259"/>
+            <ac:spMk id="14" creationId="{00000000-0000-0000-0000-000000000000}"/>
+          </ac:spMkLst>
+        </pc:spChg>
+        <pc:spChg chg="mod">
+          <ac:chgData name="Agustín Echavarría" userId="0dacd65e5bd92426" providerId="LiveId" clId="{20F5A9F9-590B-4571-87AC-ADBD672ECC31}" dt="2026-10-22T19:24:06.176" v="1306" actId="1076"/>
+          <ac:spMkLst>
+            <pc:docMk/>
+            <pc:sldMk cId="0" sldId="259"/>
+            <ac:spMk id="16" creationId="{00000000-0000-0000-0000-000000000000}"/>
+          </ac:spMkLst>
+        </pc:spChg>
+        <pc:spChg chg="mod">
+          <ac:chgData name="Agustín Echavarría" userId="0dacd65e5bd92426" providerId="LiveId" clId="{20F5A9F9-590B-4571-87AC-ADBD672ECC31}" dt="2026-10-22T19:24:06.176" v="1306" actId="1076"/>
+          <ac:spMkLst>
+            <pc:docMk/>
+            <pc:sldMk cId="0" sldId="259"/>
+            <ac:spMk id="17" creationId="{00000000-0000-0000-0000-000000000000}"/>
+          </ac:spMkLst>
+        </pc:spChg>
+        <pc:spChg chg="del">
+          <ac:chgData name="Agustín Echavarría" userId="0dacd65e5bd92426" providerId="LiveId" clId="{20F5A9F9-590B-4571-87AC-ADBD672ECC31}" dt="2026-10-22T19:23:51.342" v="1297" actId="478"/>
+          <ac:spMkLst>
+            <pc:docMk/>
+            <pc:sldMk cId="0" sldId="259"/>
+            <ac:spMk id="18" creationId="{00000000-0000-0000-0000-000000000000}"/>
+          </ac:spMkLst>
+        </pc:spChg>
+        <pc:spChg chg="del">
+          <ac:chgData name="Agustín Echavarría" userId="0dacd65e5bd92426" providerId="LiveId" clId="{20F5A9F9-590B-4571-87AC-ADBD672ECC31}" dt="2026-10-22T19:23:53.512" v="1300" actId="478"/>
+          <ac:spMkLst>
+            <pc:docMk/>
+            <pc:sldMk cId="0" sldId="259"/>
+            <ac:spMk id="19" creationId="{00000000-0000-0000-0000-000000000000}"/>
+          </ac:spMkLst>
+        </pc:spChg>
+        <pc:spChg chg="del mod">
+          <ac:chgData name="Agustín Echavarría" userId="0dacd65e5bd92426" providerId="LiveId" clId="{20F5A9F9-590B-4571-87AC-ADBD672ECC31}" dt="2026-10-22T19:23:52.913" v="1299" actId="478"/>
+          <ac:spMkLst>
+            <pc:docMk/>
+            <pc:sldMk cId="0" sldId="259"/>
+            <ac:spMk id="21" creationId="{00000000-0000-0000-0000-000000000000}"/>
+          </ac:spMkLst>
+        </pc:spChg>
+        <pc:spChg chg="del mod">
+          <ac:chgData name="Agustín Echavarría" userId="0dacd65e5bd92426" providerId="LiveId" clId="{20F5A9F9-590B-4571-87AC-ADBD672ECC31}" dt="2026-10-22T19:23:55.150" v="1303" actId="478"/>
+          <ac:spMkLst>
+            <pc:docMk/>
+            <pc:sldMk cId="0" sldId="259"/>
+            <ac:spMk id="22" creationId="{00000000-0000-0000-0000-000000000000}"/>
+          </ac:spMkLst>
+        </pc:spChg>
+        <pc:spChg chg="add del">
+          <ac:chgData name="Agustín Echavarría" userId="0dacd65e5bd92426" providerId="LiveId" clId="{20F5A9F9-590B-4571-87AC-ADBD672ECC31}" dt="2026-10-22T19:08:46.829" v="1226" actId="478"/>
+          <ac:spMkLst>
+            <pc:docMk/>
+            <pc:sldMk cId="0" sldId="259"/>
+            <ac:spMk id="23" creationId="{00000000-0000-0000-0000-000000000000}"/>
+          </ac:spMkLst>
+        </pc:spChg>
+        <pc:picChg chg="mod">
+          <ac:chgData name="Agustín Echavarría" userId="0dacd65e5bd92426" providerId="LiveId" clId="{20F5A9F9-590B-4571-87AC-ADBD672ECC31}" dt="2026-10-22T19:24:06.176" v="1306" actId="1076"/>
+          <ac:picMkLst>
+            <pc:docMk/>
+            <pc:sldMk cId="0" sldId="259"/>
+            <ac:picMk id="15" creationId="{00000000-0000-0000-0000-000000000000}"/>
+          </ac:picMkLst>
+        </pc:picChg>
+        <pc:picChg chg="del">
+          <ac:chgData name="Agustín Echavarría" userId="0dacd65e5bd92426" providerId="LiveId" clId="{20F5A9F9-590B-4571-87AC-ADBD672ECC31}" dt="2026-10-22T19:23:54.076" v="1301" actId="478"/>
+          <ac:picMkLst>
+            <pc:docMk/>
+            <pc:sldMk cId="0" sldId="259"/>
+            <ac:picMk id="20" creationId="{00000000-0000-0000-0000-000000000000}"/>
+          </ac:picMkLst>
+        </pc:picChg>
+      </pc:sldChg>
+    </pc:docChg>
+  </pc:docChgLst>
+</pc:chgInfo>
 </file>
 
 <file path=ppt/notesMasters/notesMaster1.xml><?xml version="1.0" encoding="utf-8"?>
@@ -903,7 +1313,7 @@
           </a:prstGeom>
           <a:extLst>
             <a:ext uri="{C572A759-6A51-4108-AA02-DFA0A04FC94B}">
-              <ma14:wrappingTextBoxFlag xmlns:ma14="http://schemas.microsoft.com/office/mac/drawingml/2011/main" xmlns="" val="0"/>
+              <ma14:wrappingTextBoxFlag xmlns="" xmlns:ma14="http://schemas.microsoft.com/office/mac/drawingml/2011/main" val="0"/>
             </a:ext>
           </a:extLst>
         </p:spPr>
@@ -978,7 +1388,7 @@
           </a:prstGeom>
           <a:extLst>
             <a:ext uri="{C572A759-6A51-4108-AA02-DFA0A04FC94B}">
-              <ma14:wrappingTextBoxFlag xmlns:ma14="http://schemas.microsoft.com/office/mac/drawingml/2011/main" xmlns="" val="0"/>
+              <ma14:wrappingTextBoxFlag xmlns="" xmlns:ma14="http://schemas.microsoft.com/office/mac/drawingml/2011/main" val="0"/>
             </a:ext>
           </a:extLst>
         </p:spPr>
@@ -1307,7 +1717,7 @@
           <a:bodyPr/>
           <a:lstStyle/>
           <a:p>
-            <a:endParaRPr lang="es-AR"/>
+            <a:endParaRPr lang="es-AR" noProof="0" dirty="0"/>
           </a:p>
         </p:txBody>
       </p:sp>
@@ -1336,7 +1746,7 @@
           <a:bodyPr/>
           <a:lstStyle/>
           <a:p>
-            <a:endParaRPr lang="es-AR"/>
+            <a:endParaRPr lang="es-AR" noProof="0" dirty="0"/>
           </a:p>
         </p:txBody>
       </p:sp>
@@ -1363,7 +1773,7 @@
           <a:bodyPr/>
           <a:lstStyle/>
           <a:p>
-            <a:endParaRPr lang="es-AR"/>
+            <a:endParaRPr lang="es-AR" noProof="0" dirty="0"/>
           </a:p>
         </p:txBody>
       </p:sp>
@@ -1420,7 +1830,7 @@
               <a:buNone/>
             </a:pPr>
             <a:r>
-              <a:rPr lang="en-US" sz="5400" b="1" dirty="0">
+              <a:rPr lang="es-AR" sz="5400" b="1" noProof="0" dirty="0" err="1">
                 <a:solidFill>
                   <a:srgbClr val="FFFFFF"/>
                 </a:solidFill>
@@ -1430,7 +1840,7 @@
               </a:rPr>
               <a:t>AuraHealth</a:t>
             </a:r>
-            <a:endParaRPr lang="en-US" sz="5400" dirty="0"/>
+            <a:endParaRPr lang="es-AR" sz="5400" noProof="0" dirty="0"/>
           </a:p>
         </p:txBody>
       </p:sp>
@@ -1463,7 +1873,7 @@
               <a:buNone/>
             </a:pPr>
             <a:r>
-              <a:rPr lang="en-US" sz="2000" dirty="0">
+              <a:rPr lang="es-AR" sz="2000" noProof="0" dirty="0">
                 <a:solidFill>
                   <a:srgbClr val="02C39A"/>
                 </a:solidFill>
@@ -1473,7 +1883,7 @@
               </a:rPr>
               <a:t>Sistema integral de gestión para sala médica privada</a:t>
             </a:r>
-            <a:endParaRPr lang="en-US" sz="2000" dirty="0"/>
+            <a:endParaRPr lang="es-AR" sz="2000" noProof="0" dirty="0"/>
           </a:p>
         </p:txBody>
       </p:sp>
@@ -1502,7 +1912,7 @@
               <a:buNone/>
             </a:pPr>
             <a:r>
-              <a:rPr lang="en-US" sz="1500" b="1" dirty="0">
+              <a:rPr lang="es-AR" sz="1500" b="1" noProof="0" dirty="0">
                 <a:solidFill>
                   <a:srgbClr val="FFFFFF"/>
                 </a:solidFill>
@@ -1510,16 +1920,13 @@
                 <a:ea typeface="Calibri" pitchFamily="34" charset="-122"/>
                 <a:cs typeface="Calibri" pitchFamily="34" charset="-120"/>
               </a:rPr>
-              <a:t>Sprint 2 — Reunión de Demo</a:t>
-            </a:r>
-            <a:endParaRPr lang="en-US" sz="1500" dirty="0"/>
-          </a:p>
-          <a:p>
-            <a:pPr marL="0" indent="0">
-              <a:buNone/>
-            </a:pPr>
-            <a:r>
-              <a:rPr lang="en-US" sz="1500" i="1" dirty="0">
+              <a:t>Sprint 2 — Reunión de Demo – Servicio de correo – Flujo de turnos - Vacunas</a:t>
+            </a:r>
+            <a:endParaRPr lang="es-AR" sz="1500" noProof="0" dirty="0"/>
+          </a:p>
+          <a:p>
+            <a:r>
+              <a:rPr lang="es-AR" sz="1500" i="1" dirty="0" err="1">
                 <a:solidFill>
                   <a:srgbClr val="BFE3DF"/>
                 </a:solidFill>
@@ -1527,9 +1934,31 @@
                 <a:ea typeface="Calibri" pitchFamily="34" charset="-122"/>
                 <a:cs typeface="Calibri" pitchFamily="34" charset="-120"/>
               </a:rPr>
-              <a:t>Fecha y participantes: a confirmar</a:t>
-            </a:r>
-            <a:endParaRPr lang="en-US" sz="1500" dirty="0"/>
+              <a:t>Comision</a:t>
+            </a:r>
+            <a:r>
+              <a:rPr lang="es-AR" sz="1500" i="1" dirty="0">
+                <a:solidFill>
+                  <a:srgbClr val="BFE3DF"/>
+                </a:solidFill>
+                <a:latin typeface="Calibri" pitchFamily="34" charset="0"/>
+                <a:ea typeface="Calibri" pitchFamily="34" charset="-122"/>
+                <a:cs typeface="Calibri" pitchFamily="34" charset="-120"/>
+              </a:rPr>
+              <a:t> 6 – Presenta Agustín Echavarría – 22/10/2026 19 </a:t>
+            </a:r>
+            <a:r>
+              <a:rPr lang="es-AR" sz="1500" i="1" dirty="0" err="1">
+                <a:solidFill>
+                  <a:srgbClr val="BFE3DF"/>
+                </a:solidFill>
+                <a:latin typeface="Calibri" pitchFamily="34" charset="0"/>
+                <a:ea typeface="Calibri" pitchFamily="34" charset="-122"/>
+                <a:cs typeface="Calibri" pitchFamily="34" charset="-120"/>
+              </a:rPr>
+              <a:t>hs</a:t>
+            </a:r>
+            <a:endParaRPr lang="es-AR" sz="1500" noProof="0" dirty="0"/>
           </a:p>
         </p:txBody>
       </p:sp>
@@ -1587,7 +2016,7 @@
               <a:buNone/>
             </a:pPr>
             <a:r>
-              <a:rPr lang="en-US" sz="3000" b="1" dirty="0">
+              <a:rPr lang="es-AR" sz="3000" b="1" noProof="0" dirty="0">
                 <a:solidFill>
                   <a:srgbClr val="FFFFFF"/>
                 </a:solidFill>
@@ -1597,7 +2026,7 @@
               </a:rPr>
               <a:t>Plan de demo &amp; historias de usuario implementadas</a:t>
             </a:r>
-            <a:endParaRPr lang="en-US" sz="3000" dirty="0"/>
+            <a:endParaRPr lang="es-AR" sz="3000" noProof="0" dirty="0"/>
           </a:p>
         </p:txBody>
       </p:sp>
@@ -1633,7 +2062,7 @@
           <a:bodyPr/>
           <a:lstStyle/>
           <a:p>
-            <a:endParaRPr lang="es-AR"/>
+            <a:endParaRPr lang="es-AR" noProof="0" dirty="0"/>
           </a:p>
         </p:txBody>
       </p:sp>
@@ -1660,7 +2089,7 @@
           <a:bodyPr/>
           <a:lstStyle/>
           <a:p>
-            <a:endParaRPr lang="es-AR"/>
+            <a:endParaRPr lang="es-AR" noProof="0" dirty="0"/>
           </a:p>
         </p:txBody>
       </p:sp>
@@ -1713,7 +2142,7 @@
               <a:buNone/>
             </a:pPr>
             <a:r>
-              <a:rPr lang="en-US" sz="2000" b="1" dirty="0">
+              <a:rPr lang="es-AR" sz="2000" b="1" noProof="0" dirty="0">
                 <a:solidFill>
                   <a:srgbClr val="023E40"/>
                 </a:solidFill>
@@ -1723,7 +2152,7 @@
               </a:rPr>
               <a:t>Plan de demo</a:t>
             </a:r>
-            <a:endParaRPr lang="en-US" sz="2000" dirty="0"/>
+            <a:endParaRPr lang="es-AR" sz="2000" noProof="0" dirty="0"/>
           </a:p>
         </p:txBody>
       </p:sp>
@@ -1756,7 +2185,7 @@
               <a:buChar char="•"/>
             </a:pPr>
             <a:r>
-              <a:rPr lang="en-US" sz="1400" dirty="0">
+              <a:rPr lang="es-AR" sz="1400" noProof="0" dirty="0">
                 <a:solidFill>
                   <a:srgbClr val="1B1B1B"/>
                 </a:solidFill>
@@ -1766,7 +2195,7 @@
               </a:rPr>
               <a:t>Demo en vivo del flujo completo de cada historia de usuario del sprint, sobre el sistema funcionando.</a:t>
             </a:r>
-            <a:endParaRPr lang="en-US" sz="1400" dirty="0"/>
+            <a:endParaRPr lang="es-AR" sz="1400" noProof="0" dirty="0"/>
           </a:p>
           <a:p>
             <a:pPr marL="342900" indent="-342900">
@@ -1777,7 +2206,7 @@
               <a:buChar char="•"/>
             </a:pPr>
             <a:r>
-              <a:rPr lang="en-US" sz="1400" dirty="0">
+              <a:rPr lang="es-AR" sz="1400" noProof="0" dirty="0">
                 <a:solidFill>
                   <a:srgbClr val="1B1B1B"/>
                 </a:solidFill>
@@ -1787,28 +2216,7 @@
               </a:rPr>
               <a:t>Se recorre el camino exitoso y al menos un caso de error/borde por cada US.</a:t>
             </a:r>
-            <a:endParaRPr lang="en-US" sz="1400" dirty="0"/>
-          </a:p>
-          <a:p>
-            <a:pPr marL="342900" indent="-342900">
-              <a:spcAft>
-                <a:spcPts val="1000"/>
-              </a:spcAft>
-              <a:buSzPct val="100000"/>
-              <a:buChar char="•"/>
-            </a:pPr>
-            <a:r>
-              <a:rPr lang="en-US" sz="1400" dirty="0">
-                <a:solidFill>
-                  <a:srgbClr val="1B1B1B"/>
-                </a:solidFill>
-                <a:latin typeface="Calibri" pitchFamily="34" charset="0"/>
-                <a:ea typeface="Calibri" pitchFamily="34" charset="-122"/>
-                <a:cs typeface="Calibri" pitchFamily="34" charset="-120"/>
-              </a:rPr>
-              <a:t>Fecha, hora y participantes de la reunión: a confirmar con el equipo docente.</a:t>
-            </a:r>
-            <a:endParaRPr lang="en-US" sz="1400" dirty="0"/>
+            <a:endParaRPr lang="es-AR" sz="1400" noProof="0" dirty="0"/>
           </a:p>
         </p:txBody>
       </p:sp>
@@ -1838,7 +2246,7 @@
           <a:bodyPr/>
           <a:lstStyle/>
           <a:p>
-            <a:endParaRPr lang="es-AR"/>
+            <a:endParaRPr lang="es-AR" noProof="0" dirty="0"/>
           </a:p>
         </p:txBody>
       </p:sp>
@@ -1850,8 +2258,8 @@
         </p:nvSpPr>
         <p:spPr>
           <a:xfrm>
-            <a:off x="960120" y="4663440"/>
-            <a:ext cx="4572000" cy="1371600"/>
+            <a:off x="944880" y="4663439"/>
+            <a:ext cx="4572000" cy="1645919"/>
           </a:xfrm>
           <a:prstGeom prst="rect">
             <a:avLst/>
@@ -1867,17 +2275,72 @@
               <a:buNone/>
             </a:pPr>
             <a:r>
-              <a:rPr lang="en-US" sz="1250" i="1" dirty="0">
-                <a:solidFill>
-                  <a:srgbClr val="3E5E5A"/>
-                </a:solidFill>
-                <a:latin typeface="Calibri" pitchFamily="34" charset="0"/>
-                <a:ea typeface="Calibri" pitchFamily="34" charset="-122"/>
-                <a:cs typeface="Calibri" pitchFamily="34" charset="-120"/>
-              </a:rPr>
-              <a:t>Detalle completo de escenarios: ver documento “Plan de Demo – Sprint 2”.</a:t>
-            </a:r>
-            <a:endParaRPr lang="en-US" sz="1250" dirty="0"/>
+              <a:rPr lang="es-AR" sz="1250" noProof="0" dirty="0"/>
+              <a:t>Escenarios de esta demo: </a:t>
+            </a:r>
+          </a:p>
+          <a:p>
+            <a:pPr marL="0" indent="0">
+              <a:buNone/>
+            </a:pPr>
+            <a:r>
+              <a:rPr lang="es-AR" sz="1250" noProof="0" dirty="0"/>
+              <a:t>-Edición de plantillas de correo.</a:t>
+            </a:r>
+          </a:p>
+          <a:p>
+            <a:pPr marL="0" indent="0">
+              <a:buNone/>
+            </a:pPr>
+            <a:r>
+              <a:rPr lang="es-AR" sz="1250" noProof="0" dirty="0"/>
+              <a:t>-Manejo de catálogo de vacunas.</a:t>
+            </a:r>
+          </a:p>
+          <a:p>
+            <a:pPr marL="0" indent="0">
+              <a:buNone/>
+            </a:pPr>
+            <a:r>
+              <a:rPr lang="es-AR" sz="1250" noProof="0" dirty="0"/>
+              <a:t>-Búsqueda </a:t>
+            </a:r>
+            <a:r>
+              <a:rPr lang="es-AR" sz="1250" dirty="0"/>
+              <a:t>de turnos médicos.</a:t>
+            </a:r>
+          </a:p>
+          <a:p>
+            <a:pPr marL="0" indent="0">
+              <a:buNone/>
+            </a:pPr>
+            <a:r>
+              <a:rPr lang="es-AR" sz="1250" noProof="0" dirty="0"/>
+              <a:t>-Confirmación de re</a:t>
+            </a:r>
+            <a:r>
+              <a:rPr lang="es-AR" sz="1250" dirty="0"/>
+              <a:t>servas por email.</a:t>
+            </a:r>
+            <a:endParaRPr lang="es-AR" sz="1250" noProof="0" dirty="0"/>
+          </a:p>
+          <a:p>
+            <a:pPr marL="0" indent="0">
+              <a:buNone/>
+            </a:pPr>
+            <a:r>
+              <a:rPr lang="es-AR" sz="1250" noProof="0" dirty="0"/>
+              <a:t>-Registro de estado de turnos.</a:t>
+            </a:r>
+          </a:p>
+          <a:p>
+            <a:pPr marL="0" indent="0">
+              <a:buNone/>
+            </a:pPr>
+            <a:r>
+              <a:rPr lang="es-AR" sz="1250" noProof="0" dirty="0"/>
+              <a:t>-Revisión de bugs anteriores.</a:t>
+            </a:r>
           </a:p>
         </p:txBody>
       </p:sp>
@@ -1913,7 +2376,7 @@
           <a:bodyPr/>
           <a:lstStyle/>
           <a:p>
-            <a:endParaRPr lang="es-AR"/>
+            <a:endParaRPr lang="es-AR" noProof="0" dirty="0"/>
           </a:p>
         </p:txBody>
       </p:sp>
@@ -1940,7 +2403,7 @@
           <a:bodyPr/>
           <a:lstStyle/>
           <a:p>
-            <a:endParaRPr lang="es-AR"/>
+            <a:endParaRPr lang="es-AR" noProof="0" dirty="0"/>
           </a:p>
         </p:txBody>
       </p:sp>
@@ -1993,7 +2456,7 @@
               <a:buNone/>
             </a:pPr>
             <a:r>
-              <a:rPr lang="en-US" sz="2000" b="1" dirty="0">
+              <a:rPr lang="es-AR" sz="2000" b="1" noProof="0" dirty="0">
                 <a:solidFill>
                   <a:srgbClr val="023E40"/>
                 </a:solidFill>
@@ -2001,9 +2464,46 @@
                 <a:ea typeface="Cambria" pitchFamily="34" charset="-122"/>
                 <a:cs typeface="Cambria" pitchFamily="34" charset="-120"/>
               </a:rPr>
-              <a:t>US implementadas (9)</a:t>
-            </a:r>
-            <a:endParaRPr lang="en-US" sz="2000" dirty="0"/>
+              <a:t>US implementadas (</a:t>
+            </a:r>
+            <a:r>
+              <a:rPr lang="es-AR" sz="2000" b="1" dirty="0">
+                <a:solidFill>
+                  <a:srgbClr val="023E40"/>
+                </a:solidFill>
+                <a:latin typeface="Cambria" pitchFamily="34" charset="0"/>
+                <a:ea typeface="Cambria" pitchFamily="34" charset="-122"/>
+                <a:cs typeface="Cambria" pitchFamily="34" charset="-120"/>
+              </a:rPr>
+              <a:t>7</a:t>
+            </a:r>
+            <a:r>
+              <a:rPr lang="es-AR" sz="2000" b="1" noProof="0" dirty="0">
+                <a:solidFill>
+                  <a:srgbClr val="023E40"/>
+                </a:solidFill>
+                <a:latin typeface="Cambria" pitchFamily="34" charset="0"/>
+                <a:ea typeface="Cambria" pitchFamily="34" charset="-122"/>
+                <a:cs typeface="Cambria" pitchFamily="34" charset="-120"/>
+              </a:rPr>
+              <a:t>)</a:t>
+            </a:r>
+          </a:p>
+          <a:p>
+            <a:pPr marL="0" indent="0">
+              <a:buNone/>
+            </a:pPr>
+            <a:r>
+              <a:rPr lang="es-AR" sz="2000" b="1" dirty="0">
+                <a:solidFill>
+                  <a:srgbClr val="023E40"/>
+                </a:solidFill>
+                <a:latin typeface="Cambria" pitchFamily="34" charset="0"/>
+                <a:ea typeface="Cambria" pitchFamily="34" charset="-122"/>
+              </a:rPr>
+              <a:t>NO Implementadas (2)</a:t>
+            </a:r>
+            <a:endParaRPr lang="es-AR" sz="2000" noProof="0" dirty="0"/>
           </a:p>
         </p:txBody>
       </p:sp>
@@ -2036,7 +2536,7 @@
               <a:buChar char="•"/>
             </a:pPr>
             <a:r>
-              <a:rPr lang="en-US" sz="1350" b="1" dirty="0">
+              <a:rPr lang="es-AR" sz="1350" b="1" noProof="0" dirty="0">
                 <a:solidFill>
                   <a:srgbClr val="028090"/>
                 </a:solidFill>
@@ -2047,7 +2547,7 @@
               <a:t>US-21</a:t>
             </a:r>
             <a:r>
-              <a:rPr lang="en-US" sz="1350" dirty="0">
+              <a:rPr lang="es-AR" sz="1350" noProof="0" dirty="0">
                 <a:solidFill>
                   <a:srgbClr val="1B1B1B"/>
                 </a:solidFill>
@@ -2055,9 +2555,9 @@
                 <a:ea typeface="Calibri" pitchFamily="34" charset="-122"/>
                 <a:cs typeface="Calibri" pitchFamily="34" charset="-120"/>
               </a:rPr>
-              <a:t>  Infraestructura de envío de email (plantillas y reintentos)</a:t>
-            </a:r>
-            <a:endParaRPr lang="en-US" sz="1350" dirty="0"/>
+              <a:t>  Infraestructura de envío de email (plantillas)</a:t>
+            </a:r>
+            <a:endParaRPr lang="es-AR" sz="1350" noProof="0" dirty="0"/>
           </a:p>
           <a:p>
             <a:pPr marL="342900" indent="-342900">
@@ -2068,7 +2568,7 @@
               <a:buChar char="•"/>
             </a:pPr>
             <a:r>
-              <a:rPr lang="en-US" sz="1350" b="1" dirty="0">
+              <a:rPr lang="es-AR" sz="1350" b="1" noProof="0" dirty="0">
                 <a:solidFill>
                   <a:srgbClr val="028090"/>
                 </a:solidFill>
@@ -2079,7 +2579,7 @@
               <a:t>US-24</a:t>
             </a:r>
             <a:r>
-              <a:rPr lang="en-US" sz="1350" dirty="0">
+              <a:rPr lang="es-AR" sz="1350" noProof="0" dirty="0">
                 <a:solidFill>
                   <a:srgbClr val="1B1B1B"/>
                 </a:solidFill>
@@ -2087,9 +2587,42 @@
                 <a:ea typeface="Calibri" pitchFamily="34" charset="-122"/>
                 <a:cs typeface="Calibri" pitchFamily="34" charset="-120"/>
               </a:rPr>
-              <a:t>  Catálogo de vacunas</a:t>
-            </a:r>
-            <a:endParaRPr lang="en-US" sz="1350" dirty="0"/>
+              <a:t>  Catálogo de </a:t>
+            </a:r>
+            <a:r>
+              <a:rPr lang="es-AR" sz="1350" noProof="0" dirty="0" err="1">
+                <a:solidFill>
+                  <a:srgbClr val="1B1B1B"/>
+                </a:solidFill>
+                <a:latin typeface="Calibri" pitchFamily="34" charset="0"/>
+                <a:ea typeface="Calibri" pitchFamily="34" charset="-122"/>
+                <a:cs typeface="Calibri" pitchFamily="34" charset="-120"/>
+              </a:rPr>
+              <a:t>vacu</a:t>
+            </a:r>
+            <a:r>
+              <a:rPr lang="es-AR" sz="1350" dirty="0" err="1">
+                <a:solidFill>
+                  <a:srgbClr val="1B1B1B"/>
+                </a:solidFill>
+                <a:latin typeface="Calibri" pitchFamily="34" charset="0"/>
+                <a:ea typeface="Calibri" pitchFamily="34" charset="-122"/>
+                <a:cs typeface="Calibri" pitchFamily="34" charset="-120"/>
+              </a:rPr>
+              <a:t>na</a:t>
+            </a:r>
+            <a:r>
+              <a:rPr lang="es-AR" sz="1350" noProof="0" dirty="0">
+                <a:solidFill>
+                  <a:srgbClr val="1B1B1B"/>
+                </a:solidFill>
+                <a:latin typeface="Calibri" pitchFamily="34" charset="0"/>
+                <a:ea typeface="Calibri" pitchFamily="34" charset="-122"/>
+                <a:cs typeface="Calibri" pitchFamily="34" charset="-120"/>
+              </a:rPr>
+              <a:t>s.</a:t>
+            </a:r>
+            <a:endParaRPr lang="es-AR" sz="1350" noProof="0" dirty="0"/>
           </a:p>
           <a:p>
             <a:pPr marL="342900" indent="-342900">
@@ -2100,7 +2633,7 @@
               <a:buChar char="•"/>
             </a:pPr>
             <a:r>
-              <a:rPr lang="en-US" sz="1350" b="1" dirty="0">
+              <a:rPr lang="es-AR" sz="1350" b="1" noProof="0" dirty="0">
                 <a:solidFill>
                   <a:srgbClr val="028090"/>
                 </a:solidFill>
@@ -2111,7 +2644,7 @@
               <a:t>US-10</a:t>
             </a:r>
             <a:r>
-              <a:rPr lang="en-US" sz="1350" dirty="0">
+              <a:rPr lang="es-AR" sz="1350" noProof="0" dirty="0">
                 <a:solidFill>
                   <a:srgbClr val="1B1B1B"/>
                 </a:solidFill>
@@ -2121,7 +2654,7 @@
               </a:rPr>
               <a:t>  Búsqueda de turnos por especialidad/profesional/fecha</a:t>
             </a:r>
-            <a:endParaRPr lang="en-US" sz="1350" dirty="0"/>
+            <a:endParaRPr lang="es-AR" sz="1350" dirty="0"/>
           </a:p>
           <a:p>
             <a:pPr marL="342900" indent="-342900">
@@ -2132,9 +2665,9 @@
               <a:buChar char="•"/>
             </a:pPr>
             <a:r>
-              <a:rPr lang="en-US" sz="1350" b="1" dirty="0">
-                <a:solidFill>
-                  <a:srgbClr val="028090"/>
+              <a:rPr lang="es-AR" sz="1350" b="1" strike="sngStrike" noProof="0" dirty="0">
+                <a:solidFill>
+                  <a:srgbClr val="FF0000"/>
                 </a:solidFill>
                 <a:latin typeface="Calibri" pitchFamily="34" charset="0"/>
                 <a:ea typeface="Calibri" pitchFamily="34" charset="-122"/>
@@ -2143,9 +2676,9 @@
               <a:t>US-13</a:t>
             </a:r>
             <a:r>
-              <a:rPr lang="en-US" sz="1350" dirty="0">
-                <a:solidFill>
-                  <a:srgbClr val="1B1B1B"/>
+              <a:rPr lang="es-AR" sz="1350" strike="sngStrike" noProof="0" dirty="0">
+                <a:solidFill>
+                  <a:srgbClr val="FF0000"/>
                 </a:solidFill>
                 <a:latin typeface="Calibri" pitchFamily="34" charset="0"/>
                 <a:ea typeface="Calibri" pitchFamily="34" charset="-122"/>
@@ -2153,7 +2686,11 @@
               </a:rPr>
               <a:t>  Reserva de turno con control de concurrencia</a:t>
             </a:r>
-            <a:endParaRPr lang="en-US" sz="1350" dirty="0"/>
+            <a:endParaRPr lang="es-AR" sz="1350" strike="sngStrike" noProof="0" dirty="0">
+              <a:solidFill>
+                <a:srgbClr val="FF0000"/>
+              </a:solidFill>
+            </a:endParaRPr>
           </a:p>
           <a:p>
             <a:pPr marL="342900" indent="-342900">
@@ -2164,7 +2701,7 @@
               <a:buChar char="•"/>
             </a:pPr>
             <a:r>
-              <a:rPr lang="en-US" sz="1350" b="1" dirty="0">
+              <a:rPr lang="es-AR" sz="1350" b="1" noProof="0" dirty="0">
                 <a:solidFill>
                   <a:srgbClr val="028090"/>
                 </a:solidFill>
@@ -2175,7 +2712,7 @@
               <a:t>US-14</a:t>
             </a:r>
             <a:r>
-              <a:rPr lang="en-US" sz="1350" dirty="0">
+              <a:rPr lang="es-AR" sz="1350" noProof="0" dirty="0">
                 <a:solidFill>
                   <a:srgbClr val="1B1B1B"/>
                 </a:solidFill>
@@ -2185,7 +2722,7 @@
               </a:rPr>
               <a:t>  Confirmación de la reserva por email</a:t>
             </a:r>
-            <a:endParaRPr lang="en-US" sz="1350" dirty="0"/>
+            <a:endParaRPr lang="es-AR" sz="1350" noProof="0" dirty="0"/>
           </a:p>
           <a:p>
             <a:pPr marL="342900" indent="-342900">
@@ -2196,9 +2733,9 @@
               <a:buChar char="•"/>
             </a:pPr>
             <a:r>
-              <a:rPr lang="en-US" sz="1350" b="1" dirty="0">
-                <a:solidFill>
-                  <a:srgbClr val="028090"/>
+              <a:rPr lang="es-AR" sz="1350" b="1" strike="sngStrike" noProof="0" dirty="0">
+                <a:solidFill>
+                  <a:srgbClr val="7030A0"/>
                 </a:solidFill>
                 <a:latin typeface="Calibri" pitchFamily="34" charset="0"/>
                 <a:ea typeface="Calibri" pitchFamily="34" charset="-122"/>
@@ -2207,9 +2744,9 @@
               <a:t>US-15</a:t>
             </a:r>
             <a:r>
-              <a:rPr lang="en-US" sz="1350" dirty="0">
-                <a:solidFill>
-                  <a:srgbClr val="1B1B1B"/>
+              <a:rPr lang="es-AR" sz="1350" strike="sngStrike" noProof="0" dirty="0">
+                <a:solidFill>
+                  <a:srgbClr val="7030A0"/>
                 </a:solidFill>
                 <a:latin typeface="Calibri" pitchFamily="34" charset="0"/>
                 <a:ea typeface="Calibri" pitchFamily="34" charset="-122"/>
@@ -2217,7 +2754,11 @@
               </a:rPr>
               <a:t>  Recordatorio automático de turno</a:t>
             </a:r>
-            <a:endParaRPr lang="en-US" sz="1350" dirty="0"/>
+            <a:endParaRPr lang="es-AR" sz="1350" strike="sngStrike" noProof="0" dirty="0">
+              <a:solidFill>
+                <a:srgbClr val="7030A0"/>
+              </a:solidFill>
+            </a:endParaRPr>
           </a:p>
           <a:p>
             <a:pPr marL="342900" indent="-342900">
@@ -2228,9 +2769,9 @@
               <a:buChar char="•"/>
             </a:pPr>
             <a:r>
-              <a:rPr lang="en-US" sz="1350" b="1" dirty="0">
-                <a:solidFill>
-                  <a:srgbClr val="028090"/>
+              <a:rPr lang="es-AR" sz="1350" b="1" strike="sngStrike" noProof="0" dirty="0">
+                <a:solidFill>
+                  <a:srgbClr val="FF0000"/>
                 </a:solidFill>
                 <a:latin typeface="Calibri" pitchFamily="34" charset="0"/>
                 <a:ea typeface="Calibri" pitchFamily="34" charset="-122"/>
@@ -2239,9 +2780,9 @@
               <a:t>US-16</a:t>
             </a:r>
             <a:r>
-              <a:rPr lang="en-US" sz="1350" dirty="0">
-                <a:solidFill>
-                  <a:srgbClr val="1B1B1B"/>
+              <a:rPr lang="es-AR" sz="1350" strike="sngStrike" noProof="0" dirty="0">
+                <a:solidFill>
+                  <a:srgbClr val="FF0000"/>
                 </a:solidFill>
                 <a:latin typeface="Calibri" pitchFamily="34" charset="0"/>
                 <a:ea typeface="Calibri" pitchFamily="34" charset="-122"/>
@@ -2249,7 +2790,11 @@
               </a:rPr>
               <a:t>  Cancelación de turno con liberación del horario</a:t>
             </a:r>
-            <a:endParaRPr lang="en-US" sz="1350" dirty="0"/>
+            <a:endParaRPr lang="es-AR" sz="1350" strike="sngStrike" noProof="0" dirty="0">
+              <a:solidFill>
+                <a:srgbClr val="FF0000"/>
+              </a:solidFill>
+            </a:endParaRPr>
           </a:p>
           <a:p>
             <a:pPr marL="342900" indent="-342900">
@@ -2260,9 +2805,9 @@
               <a:buChar char="•"/>
             </a:pPr>
             <a:r>
-              <a:rPr lang="en-US" sz="1350" b="1" dirty="0">
-                <a:solidFill>
-                  <a:srgbClr val="028090"/>
+              <a:rPr lang="es-AR" sz="1350" b="1" strike="sngStrike" noProof="0" dirty="0">
+                <a:solidFill>
+                  <a:srgbClr val="7030A0"/>
                 </a:solidFill>
                 <a:latin typeface="Calibri" pitchFamily="34" charset="0"/>
                 <a:ea typeface="Calibri" pitchFamily="34" charset="-122"/>
@@ -2271,9 +2816,9 @@
               <a:t>US-18</a:t>
             </a:r>
             <a:r>
-              <a:rPr lang="en-US" sz="1350" dirty="0">
-                <a:solidFill>
-                  <a:srgbClr val="1B1B1B"/>
+              <a:rPr lang="es-AR" sz="1350" strike="sngStrike" noProof="0" dirty="0">
+                <a:solidFill>
+                  <a:srgbClr val="7030A0"/>
                 </a:solidFill>
                 <a:latin typeface="Calibri" pitchFamily="34" charset="0"/>
                 <a:ea typeface="Calibri" pitchFamily="34" charset="-122"/>
@@ -2281,7 +2826,6 @@
               </a:rPr>
               <a:t>  Registro de estado del turno (cumplido/ausente/cancelado)</a:t>
             </a:r>
-            <a:endParaRPr lang="en-US" sz="1350" dirty="0"/>
           </a:p>
           <a:p>
             <a:pPr marL="342900" indent="-342900">
@@ -2292,9 +2836,9 @@
               <a:buChar char="•"/>
             </a:pPr>
             <a:r>
-              <a:rPr lang="en-US" sz="1350" b="1" dirty="0">
-                <a:solidFill>
-                  <a:srgbClr val="028090"/>
+              <a:rPr lang="es-AR" sz="1350" b="1" noProof="0" dirty="0">
+                <a:solidFill>
+                  <a:schemeClr val="accent1"/>
                 </a:solidFill>
                 <a:latin typeface="Calibri" pitchFamily="34" charset="0"/>
                 <a:ea typeface="Calibri" pitchFamily="34" charset="-122"/>
@@ -2303,17 +2847,14 @@
               <a:t>US-64</a:t>
             </a:r>
             <a:r>
-              <a:rPr lang="en-US" sz="1350" dirty="0">
-                <a:solidFill>
-                  <a:srgbClr val="1B1B1B"/>
-                </a:solidFill>
+              <a:rPr lang="es-AR" sz="1350" noProof="0" dirty="0">
                 <a:latin typeface="Calibri" pitchFamily="34" charset="0"/>
                 <a:ea typeface="Calibri" pitchFamily="34" charset="-122"/>
                 <a:cs typeface="Calibri" pitchFamily="34" charset="-120"/>
               </a:rPr>
               <a:t>  Reserva de turno a nombre de otra persona</a:t>
             </a:r>
-            <a:endParaRPr lang="en-US" sz="1350" dirty="0"/>
+            <a:endParaRPr lang="es-AR" sz="1350" noProof="0" dirty="0"/>
           </a:p>
         </p:txBody>
       </p:sp>
@@ -2337,7 +2878,7 @@
           </a:prstGeom>
           <a:extLst>
             <a:ext uri="{C572A759-6A51-4108-AA02-DFA0A04FC94B}">
-              <ma14:wrappingTextBoxFlag xmlns:ma14="http://schemas.microsoft.com/office/mac/drawingml/2011/main" xmlns="" val="0"/>
+              <ma14:wrappingTextBoxFlag xmlns="" xmlns:ma14="http://schemas.microsoft.com/office/mac/drawingml/2011/main" val="0"/>
             </a:ext>
           </a:extLst>
         </p:spPr>
@@ -2355,10 +2896,10 @@
           <a:p>
             <a:pPr algn="l"/>
             <a:fld id="{F7021451-1387-4CA6-816F-3879F97B5CBC}" type="slidenum">
-              <a:rPr lang="en-US" b="0"/>
+              <a:rPr lang="es-AR" b="0" noProof="0" smtClean="0"/>
               <a:t>2</a:t>
             </a:fld>
-            <a:endParaRPr lang="en-US"/>
+            <a:endParaRPr lang="es-AR" noProof="0" dirty="0"/>
           </a:p>
         </p:txBody>
       </p:sp>
@@ -2416,7 +2957,7 @@
               <a:buNone/>
             </a:pPr>
             <a:r>
-              <a:rPr lang="en-US" sz="3000" b="1" dirty="0">
+              <a:rPr lang="es-AR" sz="3000" b="1" noProof="0" dirty="0">
                 <a:solidFill>
                   <a:srgbClr val="FFFFFF"/>
                 </a:solidFill>
@@ -2426,7 +2967,7 @@
               </a:rPr>
               <a:t>Próximo sprint &amp; métricas</a:t>
             </a:r>
-            <a:endParaRPr lang="en-US" sz="3000" dirty="0"/>
+            <a:endParaRPr lang="es-AR" sz="3000" noProof="0" dirty="0"/>
           </a:p>
         </p:txBody>
       </p:sp>
@@ -2462,7 +3003,7 @@
           <a:bodyPr/>
           <a:lstStyle/>
           <a:p>
-            <a:endParaRPr lang="es-AR"/>
+            <a:endParaRPr lang="es-AR" noProof="0" dirty="0"/>
           </a:p>
         </p:txBody>
       </p:sp>
@@ -2489,7 +3030,7 @@
           <a:bodyPr/>
           <a:lstStyle/>
           <a:p>
-            <a:endParaRPr lang="es-AR"/>
+            <a:endParaRPr lang="es-AR" noProof="0" dirty="0"/>
           </a:p>
         </p:txBody>
       </p:sp>
@@ -2526,7 +3067,7 @@
         <p:spPr>
           <a:xfrm>
             <a:off x="1783080" y="1691640"/>
-            <a:ext cx="3840480" cy="548640"/>
+            <a:ext cx="3953486" cy="548640"/>
           </a:xfrm>
           <a:prstGeom prst="rect">
             <a:avLst/>
@@ -2542,7 +3083,7 @@
               <a:buNone/>
             </a:pPr>
             <a:r>
-              <a:rPr lang="en-US" sz="1900" b="1" dirty="0">
+              <a:rPr lang="es-AR" sz="1900" b="1" noProof="0" dirty="0">
                 <a:solidFill>
                   <a:srgbClr val="023E40"/>
                 </a:solidFill>
@@ -2552,7 +3093,25 @@
               </a:rPr>
               <a:t>Qué se hará en Sprint 3</a:t>
             </a:r>
-            <a:endParaRPr lang="en-US" sz="1900" dirty="0"/>
+          </a:p>
+          <a:p>
+            <a:pPr marL="0" indent="0">
+              <a:buNone/>
+            </a:pPr>
+            <a:r>
+              <a:rPr lang="es-AR" sz="1400" dirty="0"/>
+              <a:t>Vacunas – Pagos – Reportes –</a:t>
+            </a:r>
+          </a:p>
+          <a:p>
+            <a:pPr marL="0" indent="0">
+              <a:buNone/>
+            </a:pPr>
+            <a:r>
+              <a:rPr lang="es-AR" sz="1400" dirty="0"/>
+              <a:t> Fichas medicas - Administrativo</a:t>
+            </a:r>
+            <a:endParaRPr lang="es-AR" sz="1400" noProof="0" dirty="0"/>
           </a:p>
         </p:txBody>
       </p:sp>
@@ -2585,7 +3144,7 @@
               <a:buChar char="•"/>
             </a:pPr>
             <a:r>
-              <a:rPr lang="en-US" sz="1200" b="1" dirty="0">
+              <a:rPr lang="es-AR" sz="1200" b="1" noProof="0" dirty="0">
                 <a:solidFill>
                   <a:srgbClr val="05668D"/>
                 </a:solidFill>
@@ -2596,7 +3155,7 @@
               <a:t>US-63</a:t>
             </a:r>
             <a:r>
-              <a:rPr lang="en-US" sz="1200" dirty="0">
+              <a:rPr lang="es-AR" sz="1200" noProof="0" dirty="0">
                 <a:solidFill>
                   <a:srgbClr val="1B1B1B"/>
                 </a:solidFill>
@@ -2604,9 +3163,20 @@
                 <a:ea typeface="Calibri" pitchFamily="34" charset="-122"/>
                 <a:cs typeface="Calibri" pitchFamily="34" charset="-120"/>
               </a:rPr>
-              <a:t>  Agenda del vacunatorio</a:t>
-            </a:r>
-            <a:endParaRPr lang="en-US" sz="1200" dirty="0"/>
+              <a:t>  Agenda del </a:t>
+            </a:r>
+            <a:r>
+              <a:rPr lang="es-AR" sz="1200" noProof="0" dirty="0" err="1">
+                <a:solidFill>
+                  <a:srgbClr val="1B1B1B"/>
+                </a:solidFill>
+                <a:latin typeface="Calibri" pitchFamily="34" charset="0"/>
+                <a:ea typeface="Calibri" pitchFamily="34" charset="-122"/>
+                <a:cs typeface="Calibri" pitchFamily="34" charset="-120"/>
+              </a:rPr>
+              <a:t>vacunatorio</a:t>
+            </a:r>
+            <a:endParaRPr lang="es-AR" sz="1200" noProof="0" dirty="0"/>
           </a:p>
           <a:p>
             <a:pPr marL="342900" indent="-342900">
@@ -2617,7 +3187,7 @@
               <a:buChar char="•"/>
             </a:pPr>
             <a:r>
-              <a:rPr lang="en-US" sz="1200" b="1" dirty="0">
+              <a:rPr lang="es-AR" sz="1200" b="1" noProof="0" dirty="0">
                 <a:solidFill>
                   <a:srgbClr val="05668D"/>
                 </a:solidFill>
@@ -2628,7 +3198,7 @@
               <a:t>US-33</a:t>
             </a:r>
             <a:r>
-              <a:rPr lang="en-US" sz="1200" dirty="0">
+              <a:rPr lang="es-AR" sz="1200" noProof="0" dirty="0">
                 <a:solidFill>
                   <a:srgbClr val="1B1B1B"/>
                 </a:solidFill>
@@ -2638,7 +3208,7 @@
               </a:rPr>
               <a:t>  Precio de consulta por obra social</a:t>
             </a:r>
-            <a:endParaRPr lang="en-US" sz="1200" dirty="0"/>
+            <a:endParaRPr lang="es-AR" sz="1200" noProof="0" dirty="0"/>
           </a:p>
           <a:p>
             <a:pPr marL="342900" indent="-342900">
@@ -2649,7 +3219,7 @@
               <a:buChar char="•"/>
             </a:pPr>
             <a:r>
-              <a:rPr lang="en-US" sz="1200" b="1" dirty="0">
+              <a:rPr lang="es-AR" sz="1200" b="1" noProof="0" dirty="0">
                 <a:solidFill>
                   <a:srgbClr val="05668D"/>
                 </a:solidFill>
@@ -2660,7 +3230,7 @@
               <a:t>US-32</a:t>
             </a:r>
             <a:r>
-              <a:rPr lang="en-US" sz="1200" dirty="0">
+              <a:rPr lang="es-AR" sz="1200" noProof="0" dirty="0">
                 <a:solidFill>
                   <a:srgbClr val="1B1B1B"/>
                 </a:solidFill>
@@ -2670,7 +3240,7 @@
               </a:rPr>
               <a:t>  Gestión de cobertura médica</a:t>
             </a:r>
-            <a:endParaRPr lang="en-US" sz="1200" dirty="0"/>
+            <a:endParaRPr lang="es-AR" sz="1200" noProof="0" dirty="0"/>
           </a:p>
           <a:p>
             <a:pPr marL="342900" indent="-342900">
@@ -2681,7 +3251,7 @@
               <a:buChar char="•"/>
             </a:pPr>
             <a:r>
-              <a:rPr lang="en-US" sz="1200" b="1" dirty="0">
+              <a:rPr lang="es-AR" sz="1200" b="1" noProof="0" dirty="0">
                 <a:solidFill>
                   <a:srgbClr val="05668D"/>
                 </a:solidFill>
@@ -2692,7 +3262,7 @@
               <a:t>US-39</a:t>
             </a:r>
             <a:r>
-              <a:rPr lang="en-US" sz="1200" dirty="0">
+              <a:rPr lang="es-AR" sz="1200" noProof="0" dirty="0">
                 <a:solidFill>
                   <a:srgbClr val="1B1B1B"/>
                 </a:solidFill>
@@ -2702,7 +3272,7 @@
               </a:rPr>
               <a:t>  Ficha de diagnóstico</a:t>
             </a:r>
-            <a:endParaRPr lang="en-US" sz="1200" dirty="0"/>
+            <a:endParaRPr lang="es-AR" sz="1200" noProof="0" dirty="0"/>
           </a:p>
           <a:p>
             <a:pPr marL="342900" indent="-342900">
@@ -2713,7 +3283,7 @@
               <a:buChar char="•"/>
             </a:pPr>
             <a:r>
-              <a:rPr lang="en-US" sz="1200" b="1" dirty="0">
+              <a:rPr lang="es-AR" sz="1200" b="1" noProof="0" dirty="0">
                 <a:solidFill>
                   <a:srgbClr val="05668D"/>
                 </a:solidFill>
@@ -2724,7 +3294,7 @@
               <a:t>US-45</a:t>
             </a:r>
             <a:r>
-              <a:rPr lang="en-US" sz="1200" dirty="0">
+              <a:rPr lang="es-AR" sz="1200" noProof="0" dirty="0">
                 <a:solidFill>
                   <a:srgbClr val="1B1B1B"/>
                 </a:solidFill>
@@ -2734,7 +3304,7 @@
               </a:rPr>
               <a:t>  Reporte de turnos por especialidad</a:t>
             </a:r>
-            <a:endParaRPr lang="en-US" sz="1200" dirty="0"/>
+            <a:endParaRPr lang="es-AR" sz="1200" noProof="0" dirty="0"/>
           </a:p>
           <a:p>
             <a:pPr marL="342900" indent="-342900">
@@ -2745,7 +3315,7 @@
               <a:buChar char="•"/>
             </a:pPr>
             <a:r>
-              <a:rPr lang="en-US" sz="1200" b="1" dirty="0">
+              <a:rPr lang="es-AR" sz="1200" b="1" noProof="0" dirty="0">
                 <a:solidFill>
                   <a:srgbClr val="05668D"/>
                 </a:solidFill>
@@ -2756,7 +3326,7 @@
               <a:t>US-48</a:t>
             </a:r>
             <a:r>
-              <a:rPr lang="en-US" sz="1200" dirty="0">
+              <a:rPr lang="es-AR" sz="1200" noProof="0" dirty="0">
                 <a:solidFill>
                   <a:srgbClr val="1B1B1B"/>
                 </a:solidFill>
@@ -2766,7 +3336,7 @@
               </a:rPr>
               <a:t>  Reporte de asistencia y ausentismo</a:t>
             </a:r>
-            <a:endParaRPr lang="en-US" sz="1200" dirty="0"/>
+            <a:endParaRPr lang="es-AR" sz="1200" noProof="0" dirty="0"/>
           </a:p>
           <a:p>
             <a:pPr marL="342900" indent="-342900">
@@ -2777,7 +3347,7 @@
               <a:buChar char="•"/>
             </a:pPr>
             <a:r>
-              <a:rPr lang="en-US" sz="1200" b="1" dirty="0">
+              <a:rPr lang="es-AR" sz="1200" b="1" noProof="0" dirty="0">
                 <a:solidFill>
                   <a:srgbClr val="05668D"/>
                 </a:solidFill>
@@ -2788,7 +3358,7 @@
               <a:t>US-30</a:t>
             </a:r>
             <a:r>
-              <a:rPr lang="en-US" sz="1200" dirty="0">
+              <a:rPr lang="es-AR" sz="1200" noProof="0" dirty="0">
                 <a:solidFill>
                   <a:srgbClr val="1B1B1B"/>
                 </a:solidFill>
@@ -2798,7 +3368,7 @@
               </a:rPr>
               <a:t>  Bloqueo de turnos de franja publicada</a:t>
             </a:r>
-            <a:endParaRPr lang="en-US" sz="1200" dirty="0"/>
+            <a:endParaRPr lang="es-AR" sz="1200" noProof="0" dirty="0"/>
           </a:p>
           <a:p>
             <a:pPr marL="342900" indent="-342900">
@@ -2809,7 +3379,7 @@
               <a:buChar char="•"/>
             </a:pPr>
             <a:r>
-              <a:rPr lang="en-US" sz="1200" b="1" dirty="0">
+              <a:rPr lang="es-AR" sz="1200" b="1" noProof="0" dirty="0">
                 <a:solidFill>
                   <a:srgbClr val="05668D"/>
                 </a:solidFill>
@@ -2820,7 +3390,7 @@
               <a:t>US-28</a:t>
             </a:r>
             <a:r>
-              <a:rPr lang="en-US" sz="1200" dirty="0">
+              <a:rPr lang="es-AR" sz="1200" noProof="0" dirty="0">
                 <a:solidFill>
                   <a:srgbClr val="1B1B1B"/>
                 </a:solidFill>
@@ -2830,7 +3400,7 @@
               </a:rPr>
               <a:t>  Turno de vacunación</a:t>
             </a:r>
-            <a:endParaRPr lang="en-US" sz="1200" dirty="0"/>
+            <a:endParaRPr lang="es-AR" sz="1200" noProof="0" dirty="0"/>
           </a:p>
           <a:p>
             <a:pPr marL="342900" indent="-342900">
@@ -2841,7 +3411,7 @@
               <a:buChar char="•"/>
             </a:pPr>
             <a:r>
-              <a:rPr lang="en-US" sz="1200" b="1" dirty="0">
+              <a:rPr lang="es-AR" sz="1200" b="1" noProof="0" dirty="0">
                 <a:solidFill>
                   <a:srgbClr val="05668D"/>
                 </a:solidFill>
@@ -2852,7 +3422,7 @@
               <a:t>US-34</a:t>
             </a:r>
             <a:r>
-              <a:rPr lang="en-US" sz="1200" dirty="0">
+              <a:rPr lang="es-AR" sz="1200" noProof="0" dirty="0">
                 <a:solidFill>
                   <a:srgbClr val="1B1B1B"/>
                 </a:solidFill>
@@ -2862,7 +3432,7 @@
               </a:rPr>
               <a:t>  Cálculo del importe según obra social</a:t>
             </a:r>
-            <a:endParaRPr lang="en-US" sz="1200" dirty="0"/>
+            <a:endParaRPr lang="es-AR" sz="1200" noProof="0" dirty="0"/>
           </a:p>
           <a:p>
             <a:pPr marL="342900" indent="-342900">
@@ -2873,7 +3443,7 @@
               <a:buChar char="•"/>
             </a:pPr>
             <a:r>
-              <a:rPr lang="en-US" sz="1200" b="1" dirty="0">
+              <a:rPr lang="es-AR" sz="1200" b="1" noProof="0" dirty="0">
                 <a:solidFill>
                   <a:srgbClr val="05668D"/>
                 </a:solidFill>
@@ -2884,7 +3454,7 @@
               <a:t>US-22</a:t>
             </a:r>
             <a:r>
-              <a:rPr lang="en-US" sz="1200" dirty="0">
+              <a:rPr lang="es-AR" sz="1200" noProof="0" dirty="0">
                 <a:solidFill>
                   <a:srgbClr val="1B1B1B"/>
                 </a:solidFill>
@@ -2894,7 +3464,7 @@
               </a:rPr>
               <a:t>  Aviso por email de franja bloqueada</a:t>
             </a:r>
-            <a:endParaRPr lang="en-US" sz="1200" dirty="0"/>
+            <a:endParaRPr lang="es-AR" sz="1200" noProof="0" dirty="0"/>
           </a:p>
         </p:txBody>
       </p:sp>
@@ -2930,7 +3500,7 @@
           <a:bodyPr/>
           <a:lstStyle/>
           <a:p>
-            <a:endParaRPr lang="es-AR"/>
+            <a:endParaRPr lang="es-AR" noProof="0" dirty="0"/>
           </a:p>
         </p:txBody>
       </p:sp>
@@ -2957,7 +3527,7 @@
           <a:bodyPr/>
           <a:lstStyle/>
           <a:p>
-            <a:endParaRPr lang="es-AR"/>
+            <a:endParaRPr lang="es-AR" noProof="0" dirty="0"/>
           </a:p>
         </p:txBody>
       </p:sp>
@@ -3010,7 +3580,7 @@
               <a:buNone/>
             </a:pPr>
             <a:r>
-              <a:rPr lang="en-US" sz="1900" b="1" dirty="0">
+              <a:rPr lang="es-AR" sz="1900" b="1" noProof="0" dirty="0">
                 <a:solidFill>
                   <a:srgbClr val="023E40"/>
                 </a:solidFill>
@@ -3020,7 +3590,7 @@
               </a:rPr>
               <a:t>Métricas del sprint</a:t>
             </a:r>
-            <a:endParaRPr lang="en-US" sz="1900" dirty="0"/>
+            <a:endParaRPr lang="es-AR" sz="1900" noProof="0" dirty="0"/>
           </a:p>
         </p:txBody>
       </p:sp>
@@ -3053,7 +3623,7 @@
               <a:buChar char="•"/>
             </a:pPr>
             <a:r>
-              <a:rPr lang="en-US" sz="1150" dirty="0">
+              <a:rPr lang="es-AR" sz="1150" noProof="0" dirty="0">
                 <a:solidFill>
                   <a:srgbClr val="1B1B1B"/>
                 </a:solidFill>
@@ -3061,9 +3631,30 @@
                 <a:ea typeface="Calibri" pitchFamily="34" charset="-122"/>
                 <a:cs typeface="Calibri" pitchFamily="34" charset="-120"/>
               </a:rPr>
-              <a:t>Cantidad de historias de usuario implementadas por sprint: A completar</a:t>
-            </a:r>
-            <a:endParaRPr lang="en-US" sz="1150" dirty="0"/>
+              <a:t>Cantidad de historias de usuario implementadas por sprint: </a:t>
+            </a:r>
+            <a:r>
+              <a:rPr lang="es-AR" sz="1150" dirty="0">
+                <a:solidFill>
+                  <a:srgbClr val="1B1B1B"/>
+                </a:solidFill>
+                <a:latin typeface="Calibri" pitchFamily="34" charset="0"/>
+                <a:ea typeface="Calibri" pitchFamily="34" charset="-122"/>
+                <a:cs typeface="Calibri" pitchFamily="34" charset="-120"/>
+              </a:rPr>
+              <a:t>7</a:t>
+            </a:r>
+            <a:r>
+              <a:rPr lang="es-AR" sz="1150" noProof="0" dirty="0">
+                <a:solidFill>
+                  <a:srgbClr val="1B1B1B"/>
+                </a:solidFill>
+                <a:latin typeface="Calibri" pitchFamily="34" charset="0"/>
+                <a:ea typeface="Calibri" pitchFamily="34" charset="-122"/>
+                <a:cs typeface="Calibri" pitchFamily="34" charset="-120"/>
+              </a:rPr>
+              <a:t> </a:t>
+            </a:r>
           </a:p>
           <a:p>
             <a:pPr marL="342900" indent="-342900">
@@ -3074,7 +3665,7 @@
               <a:buChar char="•"/>
             </a:pPr>
             <a:r>
-              <a:rPr lang="en-US" sz="1150" dirty="0">
+              <a:rPr lang="es-AR" sz="1150" noProof="0" dirty="0">
                 <a:solidFill>
                   <a:srgbClr val="1B1B1B"/>
                 </a:solidFill>
@@ -3082,9 +3673,9 @@
                 <a:ea typeface="Calibri" pitchFamily="34" charset="-122"/>
                 <a:cs typeface="Calibri" pitchFamily="34" charset="-120"/>
               </a:rPr>
-              <a:t>Cantidad de bugs solucionados: A completar</a:t>
-            </a:r>
-            <a:endParaRPr lang="en-US" sz="1150" dirty="0"/>
+              <a:t>Cantidad de bugs solucionados: 4</a:t>
+            </a:r>
+            <a:endParaRPr lang="es-AR" sz="1150" noProof="0" dirty="0"/>
           </a:p>
           <a:p>
             <a:pPr marL="342900" indent="-342900">
@@ -3095,7 +3686,7 @@
               <a:buChar char="•"/>
             </a:pPr>
             <a:r>
-              <a:rPr lang="en-US" sz="1150" dirty="0">
+              <a:rPr lang="es-AR" sz="1150" noProof="0" dirty="0">
                 <a:solidFill>
                   <a:srgbClr val="1B1B1B"/>
                 </a:solidFill>
@@ -3103,9 +3694,31 @@
                 <a:ea typeface="Calibri" pitchFamily="34" charset="-122"/>
                 <a:cs typeface="Calibri" pitchFamily="34" charset="-120"/>
               </a:rPr>
-              <a:t>Cantidad de bugs/errores encontrados luego de cada feature implementada: A completar</a:t>
-            </a:r>
-            <a:endParaRPr lang="en-US" sz="1150" dirty="0"/>
+              <a:t>Cantidad de bugs/errores encontrados luego de cada </a:t>
+            </a:r>
+            <a:r>
+              <a:rPr lang="es-AR" sz="1150" noProof="0" dirty="0" err="1">
+                <a:solidFill>
+                  <a:srgbClr val="1B1B1B"/>
+                </a:solidFill>
+                <a:latin typeface="Calibri" pitchFamily="34" charset="0"/>
+                <a:ea typeface="Calibri" pitchFamily="34" charset="-122"/>
+                <a:cs typeface="Calibri" pitchFamily="34" charset="-120"/>
+              </a:rPr>
+              <a:t>feature</a:t>
+            </a:r>
+            <a:r>
+              <a:rPr lang="es-AR" sz="1150" noProof="0" dirty="0">
+                <a:solidFill>
+                  <a:srgbClr val="1B1B1B"/>
+                </a:solidFill>
+                <a:latin typeface="Calibri" pitchFamily="34" charset="0"/>
+                <a:ea typeface="Calibri" pitchFamily="34" charset="-122"/>
+                <a:cs typeface="Calibri" pitchFamily="34" charset="-120"/>
+              </a:rPr>
+              <a:t> implementada: 3</a:t>
+            </a:r>
+            <a:endParaRPr lang="es-AR" sz="1150" noProof="0" dirty="0"/>
           </a:p>
           <a:p>
             <a:pPr marL="342900" indent="-342900">
@@ -3116,7 +3729,7 @@
               <a:buChar char="•"/>
             </a:pPr>
             <a:r>
-              <a:rPr lang="en-US" sz="1150" dirty="0">
+              <a:rPr lang="es-AR" sz="1150" noProof="0" dirty="0">
                 <a:solidFill>
                   <a:srgbClr val="1B1B1B"/>
                 </a:solidFill>
@@ -3124,9 +3737,9 @@
                 <a:ea typeface="Calibri" pitchFamily="34" charset="-122"/>
                 <a:cs typeface="Calibri" pitchFamily="34" charset="-120"/>
               </a:rPr>
-              <a:t>Cantidad de requerimientos implementados y aprobados sobre el total: A completar</a:t>
-            </a:r>
-            <a:endParaRPr lang="en-US" sz="1150" dirty="0"/>
+              <a:t>Cantidad de requerimientos implementados y aprobados sobre el total: 12</a:t>
+            </a:r>
+            <a:endParaRPr lang="es-AR" sz="1150" noProof="0" dirty="0"/>
           </a:p>
           <a:p>
             <a:pPr marL="342900" indent="-342900">
@@ -3137,7 +3750,7 @@
               <a:buChar char="•"/>
             </a:pPr>
             <a:r>
-              <a:rPr lang="en-US" sz="1150" dirty="0">
+              <a:rPr lang="es-AR" sz="1150" noProof="0" dirty="0">
                 <a:solidFill>
                   <a:srgbClr val="1B1B1B"/>
                 </a:solidFill>
@@ -3145,9 +3758,9 @@
                 <a:ea typeface="Calibri" pitchFamily="34" charset="-122"/>
                 <a:cs typeface="Calibri" pitchFamily="34" charset="-120"/>
               </a:rPr>
-              <a:t>Cantidad de tareas en curso simultáneamente: A completar</a:t>
-            </a:r>
-            <a:endParaRPr lang="en-US" sz="1150" dirty="0"/>
+              <a:t>Cantidad de tareas en curso simultáneamente: 1</a:t>
+            </a:r>
+            <a:endParaRPr lang="es-AR" sz="1150" noProof="0" dirty="0"/>
           </a:p>
           <a:p>
             <a:pPr marL="342900" indent="-342900">
@@ -3158,7 +3771,7 @@
               <a:buChar char="•"/>
             </a:pPr>
             <a:r>
-              <a:rPr lang="en-US" sz="1150" dirty="0">
+              <a:rPr lang="es-AR" sz="1150" noProof="0" dirty="0">
                 <a:solidFill>
                   <a:srgbClr val="1B1B1B"/>
                 </a:solidFill>
@@ -3166,20 +3779,10 @@
                 <a:ea typeface="Calibri" pitchFamily="34" charset="-122"/>
                 <a:cs typeface="Calibri" pitchFamily="34" charset="-120"/>
               </a:rPr>
-              <a:t>Tiempo total desde que una tarea entra al backlog hasta que llega a producción: A completar</a:t>
-            </a:r>
-            <a:endParaRPr lang="en-US" sz="1150" dirty="0"/>
-          </a:p>
-          <a:p>
-            <a:pPr marL="342900" indent="-342900">
-              <a:spcAft>
-                <a:spcPts val="700"/>
-              </a:spcAft>
-              <a:buSzPct val="100000"/>
-              <a:buChar char="•"/>
-            </a:pPr>
-            <a:r>
-              <a:rPr lang="en-US" sz="1150" dirty="0" err="1">
+              <a:t>Cantidad de HU que no se terminan en el sprint sobre el total de HU del sprint: </a:t>
+            </a:r>
+            <a:r>
+              <a:rPr lang="es-AR" sz="1150" dirty="0">
                 <a:solidFill>
                   <a:srgbClr val="1B1B1B"/>
                 </a:solidFill>
@@ -3187,48 +3790,9 @@
                 <a:ea typeface="Calibri" pitchFamily="34" charset="-122"/>
                 <a:cs typeface="Calibri" pitchFamily="34" charset="-120"/>
               </a:rPr>
-              <a:t>Cantidad de HU que no se terminan en el sprint sobre el total de HU del sprint: A completar</a:t>
-            </a:r>
-            <a:endParaRPr lang="en-US" sz="1150" dirty="0"/>
-          </a:p>
-        </p:txBody>
-      </p:sp>
-      <p:sp>
-        <p:nvSpPr>
-          <p:cNvPr id="14" name="Text 10"/>
-          <p:cNvSpPr txBox="1"/>
-          <p:nvPr/>
-        </p:nvSpPr>
-        <p:spPr>
-          <a:xfrm>
-            <a:off x="6675120" y="5806440"/>
-            <a:ext cx="4572000" cy="365760"/>
-          </a:xfrm>
-          <a:prstGeom prst="rect">
-            <a:avLst/>
-          </a:prstGeom>
-          <a:noFill/>
-          <a:ln/>
-        </p:spPr>
-        <p:txBody>
-          <a:bodyPr wrap="square" lIns="0" tIns="0" rIns="0" bIns="0" rtlCol="0" anchor="ctr"/>
-          <a:lstStyle/>
-          <a:p>
-            <a:pPr marL="0" indent="0">
-              <a:buNone/>
-            </a:pPr>
-            <a:r>
-              <a:rPr lang="en-US" sz="1150" i="1" dirty="0">
-                <a:solidFill>
-                  <a:srgbClr val="3E5E5A"/>
-                </a:solidFill>
-                <a:latin typeface="Calibri" pitchFamily="34" charset="0"/>
-                <a:ea typeface="Calibri" pitchFamily="34" charset="-122"/>
-                <a:cs typeface="Calibri" pitchFamily="34" charset="-120"/>
-              </a:rPr>
-              <a:t>Valores a completar por el equipo con los datos reales del sprint.</a:t>
-            </a:r>
-            <a:endParaRPr lang="en-US" sz="1150" dirty="0"/>
+              <a:t>3</a:t>
+            </a:r>
+            <a:endParaRPr lang="es-AR" sz="1150" noProof="0" dirty="0"/>
           </a:p>
         </p:txBody>
       </p:sp>
@@ -3252,7 +3816,7 @@
           </a:prstGeom>
           <a:extLst>
             <a:ext uri="{C572A759-6A51-4108-AA02-DFA0A04FC94B}">
-              <ma14:wrappingTextBoxFlag xmlns:ma14="http://schemas.microsoft.com/office/mac/drawingml/2011/main" xmlns="" val="0"/>
+              <ma14:wrappingTextBoxFlag xmlns="" xmlns:ma14="http://schemas.microsoft.com/office/mac/drawingml/2011/main" val="0"/>
             </a:ext>
           </a:extLst>
         </p:spPr>
@@ -3270,10 +3834,10 @@
           <a:p>
             <a:pPr algn="l"/>
             <a:fld id="{F7021451-1387-4CA6-816F-3879F97B5CBC}" type="slidenum">
-              <a:rPr lang="en-US" b="0"/>
+              <a:rPr lang="es-AR" b="0" noProof="0" smtClean="0"/>
               <a:t>3</a:t>
             </a:fld>
-            <a:endParaRPr lang="en-US"/>
+            <a:endParaRPr lang="es-AR" noProof="0" dirty="0"/>
           </a:p>
         </p:txBody>
       </p:sp>
@@ -3306,7 +3870,7 @@
               <a:buChar char="•"/>
             </a:pPr>
             <a:r>
-              <a:rPr lang="en-US" sz="1200" b="1" dirty="0">
+              <a:rPr lang="es-AR" sz="1200" b="1" noProof="0" dirty="0">
                 <a:solidFill>
                   <a:srgbClr val="05668D"/>
                 </a:solidFill>
@@ -3317,7 +3881,7 @@
               <a:t>US-40</a:t>
             </a:r>
             <a:r>
-              <a:rPr lang="en-US" sz="1200" dirty="0">
+              <a:rPr lang="es-AR" sz="1200" noProof="0" dirty="0">
                 <a:solidFill>
                   <a:srgbClr val="1B1B1B"/>
                 </a:solidFill>
@@ -3327,7 +3891,7 @@
               </a:rPr>
               <a:t>  Historial consolidado del profesional</a:t>
             </a:r>
-            <a:endParaRPr lang="en-US" sz="1200" dirty="0"/>
+            <a:endParaRPr lang="es-AR" sz="1200" noProof="0" dirty="0"/>
           </a:p>
           <a:p>
             <a:pPr marL="342900" indent="-342900">
@@ -3338,7 +3902,7 @@
               <a:buChar char="•"/>
             </a:pPr>
             <a:r>
-              <a:rPr lang="en-US" sz="1200" b="1" dirty="0">
+              <a:rPr lang="es-AR" sz="1200" b="1" noProof="0" dirty="0">
                 <a:solidFill>
                   <a:srgbClr val="05668D"/>
                 </a:solidFill>
@@ -3349,7 +3913,7 @@
               <a:t>US-41</a:t>
             </a:r>
             <a:r>
-              <a:rPr lang="en-US" sz="1200" dirty="0">
+              <a:rPr lang="es-AR" sz="1200" noProof="0" dirty="0">
                 <a:solidFill>
                   <a:srgbClr val="1B1B1B"/>
                 </a:solidFill>
@@ -3359,7 +3923,7 @@
               </a:rPr>
               <a:t>  Historial clínico del paciente (lectura)</a:t>
             </a:r>
-            <a:endParaRPr lang="en-US" sz="1200" dirty="0"/>
+            <a:endParaRPr lang="es-AR" sz="1200" noProof="0" dirty="0"/>
           </a:p>
           <a:p>
             <a:pPr marL="342900" indent="-342900">
@@ -3370,7 +3934,7 @@
               <a:buChar char="•"/>
             </a:pPr>
             <a:r>
-              <a:rPr lang="en-US" sz="1200" b="1" dirty="0">
+              <a:rPr lang="es-AR" sz="1200" b="1" noProof="0" dirty="0">
                 <a:solidFill>
                   <a:srgbClr val="05668D"/>
                 </a:solidFill>
@@ -3381,7 +3945,7 @@
               <a:t>US-62</a:t>
             </a:r>
             <a:r>
-              <a:rPr lang="en-US" sz="1200" dirty="0">
+              <a:rPr lang="es-AR" sz="1200" noProof="0" dirty="0">
                 <a:solidFill>
                   <a:srgbClr val="1B1B1B"/>
                 </a:solidFill>
@@ -3391,7 +3955,7 @@
               </a:rPr>
               <a:t>  Estudios adjuntos a la ficha</a:t>
             </a:r>
-            <a:endParaRPr lang="en-US" sz="1200" dirty="0"/>
+            <a:endParaRPr lang="es-AR" sz="1200" noProof="0" dirty="0"/>
           </a:p>
           <a:p>
             <a:pPr marL="342900" indent="-342900">
@@ -3402,7 +3966,7 @@
               <a:buChar char="•"/>
             </a:pPr>
             <a:r>
-              <a:rPr lang="en-US" sz="1200" b="1" dirty="0">
+              <a:rPr lang="es-AR" sz="1200" b="1" noProof="0" dirty="0">
                 <a:solidFill>
                   <a:srgbClr val="05668D"/>
                 </a:solidFill>
@@ -3413,7 +3977,7 @@
               <a:t>US-29</a:t>
             </a:r>
             <a:r>
-              <a:rPr lang="en-US" sz="1200" dirty="0">
+              <a:rPr lang="es-AR" sz="1200" noProof="0" dirty="0">
                 <a:solidFill>
                   <a:srgbClr val="1B1B1B"/>
                 </a:solidFill>
@@ -3423,7 +3987,7 @@
               </a:rPr>
               <a:t>  Registro de dosis aplicada</a:t>
             </a:r>
-            <a:endParaRPr lang="en-US" sz="1200" dirty="0"/>
+            <a:endParaRPr lang="es-AR" sz="1200" noProof="0" dirty="0"/>
           </a:p>
           <a:p>
             <a:pPr marL="342900" indent="-342900">
@@ -3434,7 +3998,7 @@
               <a:buChar char="•"/>
             </a:pPr>
             <a:r>
-              <a:rPr lang="en-US" sz="1200" b="1" dirty="0">
+              <a:rPr lang="es-AR" sz="1200" b="1" noProof="0" dirty="0">
                 <a:solidFill>
                   <a:srgbClr val="05668D"/>
                 </a:solidFill>
@@ -3445,7 +4009,7 @@
               <a:t>US-17</a:t>
             </a:r>
             <a:r>
-              <a:rPr lang="en-US" sz="1200" dirty="0">
+              <a:rPr lang="es-AR" sz="1200" noProof="0" dirty="0">
                 <a:solidFill>
                   <a:srgbClr val="1B1B1B"/>
                 </a:solidFill>
@@ -3455,7 +4019,7 @@
               </a:rPr>
               <a:t>  Turnos desde mostrador</a:t>
             </a:r>
-            <a:endParaRPr lang="en-US" sz="1200" dirty="0"/>
+            <a:endParaRPr lang="es-AR" sz="1200" noProof="0" dirty="0"/>
           </a:p>
           <a:p>
             <a:pPr marL="342900" indent="-342900">
@@ -3466,7 +4030,7 @@
               <a:buChar char="•"/>
             </a:pPr>
             <a:r>
-              <a:rPr lang="en-US" sz="1200" b="1" dirty="0">
+              <a:rPr lang="es-AR" sz="1200" b="1" noProof="0" dirty="0">
                 <a:solidFill>
                   <a:srgbClr val="05668D"/>
                 </a:solidFill>
@@ -3477,7 +4041,7 @@
               <a:t>US-35</a:t>
             </a:r>
             <a:r>
-              <a:rPr lang="en-US" sz="1200" dirty="0">
+              <a:rPr lang="es-AR" sz="1200" noProof="0" dirty="0">
                 <a:solidFill>
                   <a:srgbClr val="1B1B1B"/>
                 </a:solidFill>
@@ -3487,7 +4051,7 @@
               </a:rPr>
               <a:t>  Registro de pago</a:t>
             </a:r>
-            <a:endParaRPr lang="en-US" sz="1200" dirty="0"/>
+            <a:endParaRPr lang="es-AR" sz="1200" noProof="0" dirty="0"/>
           </a:p>
           <a:p>
             <a:pPr marL="342900" indent="-342900">
@@ -3498,7 +4062,7 @@
               <a:buChar char="•"/>
             </a:pPr>
             <a:r>
-              <a:rPr lang="en-US" sz="1200" b="1" dirty="0">
+              <a:rPr lang="es-AR" sz="1200" b="1" noProof="0" dirty="0">
                 <a:solidFill>
                   <a:srgbClr val="05668D"/>
                 </a:solidFill>
@@ -3509,7 +4073,7 @@
               <a:t>US-44</a:t>
             </a:r>
             <a:r>
-              <a:rPr lang="en-US" sz="1200" dirty="0">
+              <a:rPr lang="es-AR" sz="1200" noProof="0" dirty="0">
                 <a:solidFill>
                   <a:srgbClr val="1B1B1B"/>
                 </a:solidFill>
@@ -3519,7 +4083,7 @@
               </a:rPr>
               <a:t>  Auditoría de accesos al historial</a:t>
             </a:r>
-            <a:endParaRPr lang="en-US" sz="1200" dirty="0"/>
+            <a:endParaRPr lang="es-AR" sz="1200" noProof="0" dirty="0"/>
           </a:p>
           <a:p>
             <a:pPr marL="342900" indent="-342900">
@@ -3530,7 +4094,7 @@
               <a:buChar char="•"/>
             </a:pPr>
             <a:r>
-              <a:rPr lang="en-US" sz="1200" b="1" dirty="0">
+              <a:rPr lang="es-AR" sz="1200" b="1" noProof="0" dirty="0">
                 <a:solidFill>
                   <a:srgbClr val="05668D"/>
                 </a:solidFill>
@@ -3541,7 +4105,7 @@
               <a:t>US-57</a:t>
             </a:r>
             <a:r>
-              <a:rPr lang="en-US" sz="1200" dirty="0">
+              <a:rPr lang="es-AR" sz="1200" noProof="0" dirty="0">
                 <a:solidFill>
                   <a:srgbClr val="1B1B1B"/>
                 </a:solidFill>
@@ -3551,7 +4115,7 @@
               </a:rPr>
               <a:t>  Carnet de vacunación</a:t>
             </a:r>
-            <a:endParaRPr lang="en-US" sz="1200" dirty="0"/>
+            <a:endParaRPr lang="es-AR" sz="1200" noProof="0" dirty="0"/>
           </a:p>
           <a:p>
             <a:pPr marL="342900" indent="-342900">
@@ -3562,7 +4126,7 @@
               <a:buChar char="•"/>
             </a:pPr>
             <a:r>
-              <a:rPr lang="en-US" sz="1200" b="1" dirty="0">
+              <a:rPr lang="es-AR" sz="1200" b="1" noProof="0" dirty="0">
                 <a:solidFill>
                   <a:srgbClr val="05668D"/>
                 </a:solidFill>
@@ -3573,7 +4137,7 @@
               <a:t>US-36</a:t>
             </a:r>
             <a:r>
-              <a:rPr lang="en-US" sz="1200" dirty="0">
+              <a:rPr lang="es-AR" sz="1200" noProof="0" dirty="0">
                 <a:solidFill>
                   <a:srgbClr val="1B1B1B"/>
                 </a:solidFill>
@@ -3583,7 +4147,7 @@
               </a:rPr>
               <a:t>  Comprobante de pago en PDF</a:t>
             </a:r>
-            <a:endParaRPr lang="en-US" sz="1200" dirty="0"/>
+            <a:endParaRPr lang="es-AR" sz="1200" noProof="0" dirty="0"/>
           </a:p>
           <a:p>
             <a:pPr marL="342900" indent="-342900">
@@ -3594,7 +4158,7 @@
               <a:buChar char="•"/>
             </a:pPr>
             <a:r>
-              <a:rPr lang="en-US" sz="1200" b="1" dirty="0">
+              <a:rPr lang="es-AR" sz="1200" b="1" noProof="0" dirty="0">
                 <a:solidFill>
                   <a:srgbClr val="05668D"/>
                 </a:solidFill>
@@ -3605,7 +4169,7 @@
               <a:t>US-47</a:t>
             </a:r>
             <a:r>
-              <a:rPr lang="en-US" sz="1200" dirty="0">
+              <a:rPr lang="es-AR" sz="1200" noProof="0" dirty="0">
                 <a:solidFill>
                   <a:srgbClr val="1B1B1B"/>
                 </a:solidFill>
@@ -3615,7 +4179,7 @@
               </a:rPr>
               <a:t>  Reporte de pagos</a:t>
             </a:r>
-            <a:endParaRPr lang="en-US" sz="1200" dirty="0"/>
+            <a:endParaRPr lang="es-AR" sz="1200" noProof="0" dirty="0"/>
           </a:p>
         </p:txBody>
       </p:sp>
@@ -3673,7 +4237,7 @@
               <a:buNone/>
             </a:pPr>
             <a:r>
-              <a:rPr lang="en-US" sz="3000" b="1" dirty="0">
+              <a:rPr lang="es-AR" sz="3000" b="1" noProof="0" dirty="0">
                 <a:solidFill>
                   <a:srgbClr val="FFFFFF"/>
                 </a:solidFill>
@@ -3683,7 +4247,7 @@
               </a:rPr>
               <a:t>Bugs encontrados</a:t>
             </a:r>
-            <a:endParaRPr lang="en-US" sz="3000" dirty="0"/>
+            <a:endParaRPr lang="es-AR" sz="3000" noProof="0" dirty="0"/>
           </a:p>
         </p:txBody>
       </p:sp>
@@ -3719,7 +4283,7 @@
           <a:bodyPr/>
           <a:lstStyle/>
           <a:p>
-            <a:endParaRPr lang="es-AR"/>
+            <a:endParaRPr lang="es-AR" noProof="0" dirty="0"/>
           </a:p>
         </p:txBody>
       </p:sp>
@@ -3746,7 +4310,7 @@
           <a:bodyPr/>
           <a:lstStyle/>
           <a:p>
-            <a:endParaRPr lang="es-AR"/>
+            <a:endParaRPr lang="es-AR" noProof="0" dirty="0"/>
           </a:p>
         </p:txBody>
       </p:sp>
@@ -3799,7 +4363,7 @@
               <a:buNone/>
             </a:pPr>
             <a:r>
-              <a:rPr lang="en-US" sz="1500" b="1" dirty="0">
+              <a:rPr lang="es-AR" sz="1500" b="1" noProof="0" dirty="0">
                 <a:solidFill>
                   <a:srgbClr val="D64550"/>
                 </a:solidFill>
@@ -3809,7 +4373,7 @@
               </a:rPr>
               <a:t>Bug 1</a:t>
             </a:r>
-            <a:endParaRPr lang="en-US" sz="1500" dirty="0"/>
+            <a:endParaRPr lang="es-AR" sz="1500" noProof="0" dirty="0"/>
           </a:p>
         </p:txBody>
       </p:sp>
@@ -3821,7 +4385,7 @@
         </p:nvSpPr>
         <p:spPr>
           <a:xfrm>
-            <a:off x="914400" y="2286000"/>
+            <a:off x="899160" y="2270904"/>
             <a:ext cx="4800600" cy="914400"/>
           </a:xfrm>
           <a:prstGeom prst="rect">
@@ -3838,7 +4402,7 @@
               <a:buNone/>
             </a:pPr>
             <a:r>
-              <a:rPr lang="en-US" sz="1300" dirty="0">
+              <a:rPr lang="es-AR" sz="1300" noProof="0" dirty="0">
                 <a:solidFill>
                   <a:srgbClr val="1B1B1B"/>
                 </a:solidFill>
@@ -3846,9 +4410,25 @@
                 <a:ea typeface="Calibri" pitchFamily="34" charset="-122"/>
                 <a:cs typeface="Calibri" pitchFamily="34" charset="-120"/>
               </a:rPr>
-              <a:t>A completar.</a:t>
-            </a:r>
-            <a:endParaRPr lang="en-US" sz="1300" dirty="0"/>
+              <a:t>La franja horaria mensual se toma sobre días ya pasados y no se puede </a:t>
+            </a:r>
+          </a:p>
+          <a:p>
+            <a:pPr marL="0" indent="0">
+              <a:buNone/>
+            </a:pPr>
+            <a:r>
+              <a:rPr lang="es-AR" sz="1300" dirty="0">
+                <a:solidFill>
+                  <a:srgbClr val="1B1B1B"/>
+                </a:solidFill>
+                <a:latin typeface="Calibri" pitchFamily="34" charset="0"/>
+                <a:ea typeface="Calibri" pitchFamily="34" charset="-122"/>
+                <a:cs typeface="Calibri" pitchFamily="34" charset="-120"/>
+              </a:rPr>
+              <a:t>avanzar.</a:t>
+            </a:r>
+            <a:endParaRPr lang="es-AR" sz="1300" noProof="0" dirty="0"/>
           </a:p>
         </p:txBody>
       </p:sp>
@@ -3884,7 +4464,7 @@
           <a:bodyPr/>
           <a:lstStyle/>
           <a:p>
-            <a:endParaRPr lang="es-AR"/>
+            <a:endParaRPr lang="es-AR" noProof="0" dirty="0"/>
           </a:p>
         </p:txBody>
       </p:sp>
@@ -3911,7 +4491,7 @@
           <a:bodyPr/>
           <a:lstStyle/>
           <a:p>
-            <a:endParaRPr lang="es-AR"/>
+            <a:endParaRPr lang="es-AR" noProof="0" dirty="0"/>
           </a:p>
         </p:txBody>
       </p:sp>
@@ -3964,7 +4544,7 @@
               <a:buNone/>
             </a:pPr>
             <a:r>
-              <a:rPr lang="en-US" sz="1500" b="1" dirty="0">
+              <a:rPr lang="es-AR" sz="1500" b="1" noProof="0" dirty="0">
                 <a:solidFill>
                   <a:srgbClr val="D64550"/>
                 </a:solidFill>
@@ -3974,7 +4554,7 @@
               </a:rPr>
               <a:t>Bug 2</a:t>
             </a:r>
-            <a:endParaRPr lang="en-US" sz="1500" dirty="0"/>
+            <a:endParaRPr lang="es-AR" sz="1500" noProof="0" dirty="0"/>
           </a:p>
         </p:txBody>
       </p:sp>
@@ -4003,7 +4583,7 @@
               <a:buNone/>
             </a:pPr>
             <a:r>
-              <a:rPr lang="en-US" sz="1300" dirty="0">
+              <a:rPr lang="es-MX" sz="1300" dirty="0">
                 <a:solidFill>
                   <a:srgbClr val="1B1B1B"/>
                 </a:solidFill>
@@ -4011,9 +4591,53 @@
                 <a:ea typeface="Calibri" pitchFamily="34" charset="-122"/>
                 <a:cs typeface="Calibri" pitchFamily="34" charset="-120"/>
               </a:rPr>
-              <a:t>A completar.</a:t>
-            </a:r>
-            <a:endParaRPr lang="en-US" sz="1300" dirty="0"/>
+              <a:t>C</a:t>
+            </a:r>
+            <a:r>
+              <a:rPr lang="es-AR" sz="1300" dirty="0" err="1">
+                <a:solidFill>
+                  <a:srgbClr val="1B1B1B"/>
+                </a:solidFill>
+                <a:latin typeface="Calibri" pitchFamily="34" charset="0"/>
+                <a:ea typeface="Calibri" pitchFamily="34" charset="-122"/>
+                <a:cs typeface="Calibri" pitchFamily="34" charset="-120"/>
+              </a:rPr>
+              <a:t>onfirmacion</a:t>
+            </a:r>
+            <a:r>
+              <a:rPr lang="es-AR" sz="1300" dirty="0">
+                <a:solidFill>
+                  <a:srgbClr val="1B1B1B"/>
+                </a:solidFill>
+                <a:latin typeface="Calibri" pitchFamily="34" charset="0"/>
+                <a:ea typeface="Calibri" pitchFamily="34" charset="-122"/>
+                <a:cs typeface="Calibri" pitchFamily="34" charset="-120"/>
+              </a:rPr>
+              <a:t> visual de los botones con </a:t>
+            </a:r>
+            <a:r>
+              <a:rPr lang="es-AR" sz="1300" dirty="0" err="1">
+                <a:solidFill>
+                  <a:srgbClr val="1B1B1B"/>
+                </a:solidFill>
+                <a:latin typeface="Calibri" pitchFamily="34" charset="0"/>
+                <a:ea typeface="Calibri" pitchFamily="34" charset="-122"/>
+                <a:cs typeface="Calibri" pitchFamily="34" charset="-120"/>
+              </a:rPr>
+              <a:t>hover</a:t>
+            </a:r>
+            <a:r>
+              <a:rPr lang="es-AR" sz="1300" dirty="0">
+                <a:solidFill>
+                  <a:srgbClr val="1B1B1B"/>
+                </a:solidFill>
+                <a:latin typeface="Calibri" pitchFamily="34" charset="0"/>
+                <a:ea typeface="Calibri" pitchFamily="34" charset="-122"/>
+                <a:cs typeface="Calibri" pitchFamily="34" charset="-120"/>
+              </a:rPr>
+              <a:t>.</a:t>
+            </a:r>
+            <a:endParaRPr lang="es-AR" sz="1300" noProof="0" dirty="0"/>
           </a:p>
         </p:txBody>
       </p:sp>
@@ -4025,7 +4649,7 @@
         </p:nvSpPr>
         <p:spPr>
           <a:xfrm>
-            <a:off x="640080" y="3611880"/>
+            <a:off x="3228004" y="3529066"/>
             <a:ext cx="5349240" cy="1965960"/>
           </a:xfrm>
           <a:prstGeom prst="roundRect">
@@ -4049,7 +4673,7 @@
           <a:bodyPr/>
           <a:lstStyle/>
           <a:p>
-            <a:endParaRPr lang="es-AR"/>
+            <a:endParaRPr lang="es-AR" noProof="0" dirty="0"/>
           </a:p>
         </p:txBody>
       </p:sp>
@@ -4061,7 +4685,7 @@
         </p:nvSpPr>
         <p:spPr>
           <a:xfrm>
-            <a:off x="914400" y="3867912"/>
+            <a:off x="3502324" y="3785098"/>
             <a:ext cx="566928" cy="566928"/>
           </a:xfrm>
           <a:prstGeom prst="ellipse">
@@ -4076,7 +4700,7 @@
           <a:bodyPr/>
           <a:lstStyle/>
           <a:p>
-            <a:endParaRPr lang="es-AR"/>
+            <a:endParaRPr lang="es-AR" noProof="0" dirty="0"/>
           </a:p>
         </p:txBody>
       </p:sp>
@@ -4096,7 +4720,7 @@
         </p:blipFill>
         <p:spPr>
           <a:xfrm>
-            <a:off x="1042416" y="3995928"/>
+            <a:off x="3630340" y="3913114"/>
             <a:ext cx="310896" cy="310896"/>
           </a:xfrm>
           <a:prstGeom prst="rect">
@@ -4112,7 +4736,7 @@
         </p:nvSpPr>
         <p:spPr>
           <a:xfrm>
-            <a:off x="1645920" y="3813048"/>
+            <a:off x="4233844" y="3730234"/>
             <a:ext cx="4069080" cy="365760"/>
           </a:xfrm>
           <a:prstGeom prst="rect">
@@ -4129,7 +4753,7 @@
               <a:buNone/>
             </a:pPr>
             <a:r>
-              <a:rPr lang="en-US" sz="1500" b="1" dirty="0">
+              <a:rPr lang="es-AR" sz="1500" b="1" noProof="0" dirty="0">
                 <a:solidFill>
                   <a:srgbClr val="D64550"/>
                 </a:solidFill>
@@ -4139,7 +4763,7 @@
               </a:rPr>
               <a:t>Bug 3</a:t>
             </a:r>
-            <a:endParaRPr lang="en-US" sz="1500" dirty="0"/>
+            <a:endParaRPr lang="es-AR" sz="1500" noProof="0" dirty="0"/>
           </a:p>
         </p:txBody>
       </p:sp>
@@ -4151,7 +4775,7 @@
         </p:nvSpPr>
         <p:spPr>
           <a:xfrm>
-            <a:off x="914400" y="4480560"/>
+            <a:off x="3502324" y="4397746"/>
             <a:ext cx="4800600" cy="914400"/>
           </a:xfrm>
           <a:prstGeom prst="rect">
@@ -4168,7 +4792,7 @@
               <a:buNone/>
             </a:pPr>
             <a:r>
-              <a:rPr lang="en-US" sz="1300" dirty="0">
+              <a:rPr lang="es-MX" sz="1300" dirty="0">
                 <a:solidFill>
                   <a:srgbClr val="1B1B1B"/>
                 </a:solidFill>
@@ -4176,164 +4800,10 @@
                 <a:ea typeface="Calibri" pitchFamily="34" charset="-122"/>
                 <a:cs typeface="Calibri" pitchFamily="34" charset="-120"/>
               </a:rPr>
-              <a:t>A completar.</a:t>
-            </a:r>
-            <a:endParaRPr lang="en-US" sz="1300" dirty="0"/>
-          </a:p>
-        </p:txBody>
-      </p:sp>
-      <p:sp>
-        <p:nvSpPr>
-          <p:cNvPr id="18" name="Shape 13"/>
-          <p:cNvSpPr/>
-          <p:nvPr/>
-        </p:nvSpPr>
-        <p:spPr>
-          <a:xfrm>
-            <a:off x="6217920" y="3611880"/>
-            <a:ext cx="5349240" cy="1965960"/>
-          </a:xfrm>
-          <a:prstGeom prst="roundRect">
-            <a:avLst>
-              <a:gd name="adj" fmla="val 4651"/>
-            </a:avLst>
-          </a:prstGeom>
-          <a:solidFill>
-            <a:srgbClr val="E9F5F3"/>
-          </a:solidFill>
-          <a:ln/>
-          <a:effectLst>
-            <a:outerShdw blurRad="76200" dist="25400" dir="5400000" algn="bl" rotWithShape="0">
-              <a:srgbClr val="1B1B1B">
-                <a:alpha val="16000"/>
-              </a:srgbClr>
-            </a:outerShdw>
-          </a:effectLst>
-        </p:spPr>
-        <p:txBody>
-          <a:bodyPr/>
-          <a:lstStyle/>
-          <a:p>
-            <a:endParaRPr lang="es-AR"/>
-          </a:p>
-        </p:txBody>
-      </p:sp>
-      <p:sp>
-        <p:nvSpPr>
-          <p:cNvPr id="19" name="Shape 14"/>
-          <p:cNvSpPr/>
-          <p:nvPr/>
-        </p:nvSpPr>
-        <p:spPr>
-          <a:xfrm>
-            <a:off x="6492240" y="3867912"/>
-            <a:ext cx="566928" cy="566928"/>
-          </a:xfrm>
-          <a:prstGeom prst="ellipse">
-            <a:avLst/>
-          </a:prstGeom>
-          <a:solidFill>
-            <a:srgbClr val="D64550"/>
-          </a:solidFill>
-          <a:ln/>
-        </p:spPr>
-        <p:txBody>
-          <a:bodyPr/>
-          <a:lstStyle/>
-          <a:p>
-            <a:endParaRPr lang="es-AR"/>
-          </a:p>
-        </p:txBody>
-      </p:sp>
-      <p:pic>
-        <p:nvPicPr>
-          <p:cNvPr id="20" name="Image 3" descr="preencoded.png"/>
-          <p:cNvPicPr>
-            <a:picLocks noChangeAspect="1"/>
-          </p:cNvPicPr>
-          <p:nvPr/>
-        </p:nvPicPr>
-        <p:blipFill>
-          <a:blip r:embed="rId3"/>
-          <a:stretch>
-            <a:fillRect/>
-          </a:stretch>
-        </p:blipFill>
-        <p:spPr>
-          <a:xfrm>
-            <a:off x="6620256" y="3995928"/>
-            <a:ext cx="310896" cy="310896"/>
-          </a:xfrm>
-          <a:prstGeom prst="rect">
-            <a:avLst/>
-          </a:prstGeom>
-        </p:spPr>
-      </p:pic>
-      <p:sp>
-        <p:nvSpPr>
-          <p:cNvPr id="21" name="Text 15"/>
-          <p:cNvSpPr txBox="1"/>
-          <p:nvPr/>
-        </p:nvSpPr>
-        <p:spPr>
-          <a:xfrm>
-            <a:off x="7223760" y="3813048"/>
-            <a:ext cx="4069080" cy="365760"/>
-          </a:xfrm>
-          <a:prstGeom prst="rect">
-            <a:avLst/>
-          </a:prstGeom>
-          <a:noFill/>
-          <a:ln/>
-        </p:spPr>
-        <p:txBody>
-          <a:bodyPr wrap="square" lIns="0" tIns="0" rIns="0" bIns="0" rtlCol="0" anchor="ctr"/>
-          <a:lstStyle/>
-          <a:p>
-            <a:pPr marL="0" indent="0">
-              <a:buNone/>
-            </a:pPr>
-            <a:r>
-              <a:rPr lang="en-US" sz="1500" b="1" dirty="0">
-                <a:solidFill>
-                  <a:srgbClr val="D64550"/>
-                </a:solidFill>
-                <a:latin typeface="Cambria" pitchFamily="34" charset="0"/>
-                <a:ea typeface="Cambria" pitchFamily="34" charset="-122"/>
-                <a:cs typeface="Cambria" pitchFamily="34" charset="-120"/>
-              </a:rPr>
-              <a:t>Bug 4</a:t>
-            </a:r>
-            <a:endParaRPr lang="en-US" sz="1500" dirty="0"/>
-          </a:p>
-        </p:txBody>
-      </p:sp>
-      <p:sp>
-        <p:nvSpPr>
-          <p:cNvPr id="22" name="Text 16"/>
-          <p:cNvSpPr txBox="1"/>
-          <p:nvPr/>
-        </p:nvSpPr>
-        <p:spPr>
-          <a:xfrm>
-            <a:off x="6492240" y="4480560"/>
-            <a:ext cx="4800600" cy="914400"/>
-          </a:xfrm>
-          <a:prstGeom prst="rect">
-            <a:avLst/>
-          </a:prstGeom>
-          <a:noFill/>
-          <a:ln/>
-        </p:spPr>
-        <p:txBody>
-          <a:bodyPr wrap="square" lIns="0" tIns="0" rIns="0" bIns="0" rtlCol="0" anchor="t"/>
-          <a:lstStyle/>
-          <a:p>
-            <a:pPr marL="0" indent="0">
-              <a:buNone/>
-            </a:pPr>
-            <a:r>
-              <a:rPr lang="en-US" sz="1300" dirty="0">
+              <a:t>V</a:t>
+            </a:r>
+            <a:r>
+              <a:rPr lang="es-AR" sz="1300" dirty="0" err="1">
                 <a:solidFill>
                   <a:srgbClr val="1B1B1B"/>
                 </a:solidFill>
@@ -4341,9 +4811,20 @@
                 <a:ea typeface="Calibri" pitchFamily="34" charset="-122"/>
                 <a:cs typeface="Calibri" pitchFamily="34" charset="-120"/>
               </a:rPr>
-              <a:t>A completar.</a:t>
-            </a:r>
-            <a:endParaRPr lang="en-US" sz="1300" dirty="0"/>
+              <a:t>alidacion</a:t>
+            </a:r>
+            <a:r>
+              <a:rPr lang="es-AR" sz="1300" dirty="0">
+                <a:solidFill>
+                  <a:srgbClr val="1B1B1B"/>
+                </a:solidFill>
+                <a:latin typeface="Calibri" pitchFamily="34" charset="0"/>
+                <a:ea typeface="Calibri" pitchFamily="34" charset="-122"/>
+                <a:cs typeface="Calibri" pitchFamily="34" charset="-120"/>
+              </a:rPr>
+              <a:t> de formularios en campos de texto.</a:t>
+            </a:r>
+            <a:endParaRPr lang="es-AR" sz="1300" noProof="0" dirty="0"/>
           </a:p>
         </p:txBody>
       </p:sp>
@@ -4372,7 +4853,7 @@
               <a:buNone/>
             </a:pPr>
             <a:r>
-              <a:rPr lang="en-US" sz="1300" i="1" dirty="0">
+              <a:rPr lang="es-AR" sz="1300" i="1" noProof="0" dirty="0">
                 <a:solidFill>
                   <a:srgbClr val="3E5E5A"/>
                 </a:solidFill>
@@ -4382,7 +4863,7 @@
               </a:rPr>
               <a:t>Reserva planificada: 3 puntos para corrección de los bugs del Sprint 2 durante el Sprint 3.</a:t>
             </a:r>
-            <a:endParaRPr lang="en-US" sz="1300" dirty="0"/>
+            <a:endParaRPr lang="es-AR" sz="1300" noProof="0" dirty="0"/>
           </a:p>
         </p:txBody>
       </p:sp>
@@ -4406,7 +4887,7 @@
           </a:prstGeom>
           <a:extLst>
             <a:ext uri="{C572A759-6A51-4108-AA02-DFA0A04FC94B}">
-              <ma14:wrappingTextBoxFlag xmlns:ma14="http://schemas.microsoft.com/office/mac/drawingml/2011/main" xmlns="" val="0"/>
+              <ma14:wrappingTextBoxFlag xmlns="" xmlns:ma14="http://schemas.microsoft.com/office/mac/drawingml/2011/main" val="0"/>
             </a:ext>
           </a:extLst>
         </p:spPr>
@@ -4424,10 +4905,10 @@
           <a:p>
             <a:pPr algn="l"/>
             <a:fld id="{F7021451-1387-4CA6-816F-3879F97B5CBC}" type="slidenum">
-              <a:rPr lang="en-US" b="0"/>
+              <a:rPr lang="es-AR" b="0" noProof="0" smtClean="0"/>
               <a:t>4</a:t>
             </a:fld>
-            <a:endParaRPr lang="en-US"/>
+            <a:endParaRPr lang="es-AR" noProof="0" dirty="0"/>
           </a:p>
         </p:txBody>
       </p:sp>

</xml_diff>